<commit_message>
Make the fairness-bandwidth frontier readable and complete
Replace the second-order-cone shorthand with a plain-language construction of
each upper-bound point: set a Jain target, enforce every link capacity, and
maximize aggregate rate. Overlay every scheme re-measured at the official 20k
workload so architecture trade-offs can be read from one consistent chart
instead of inferred across later slides.

Co-authored-by: Cursor <cursoragent@cursor.com>
</commit_message>
<xml_diff>
--- a/ppt/ring2-write-fairness.pptx
+++ b/ppt/ring2-write-fairness.pptx
@@ -10797,8 +10797,8 @@
         </p:blipFill>
         <p:spPr>
           <a:xfrm>
-            <a:off x="566928" y="1689708"/>
-            <a:ext cx="7452360" cy="3533446"/>
+            <a:off x="566928" y="1673215"/>
+            <a:ext cx="7452360" cy="3566433"/>
           </a:xfrm>
           <a:prstGeom prst="rect">
             <a:avLst/>
@@ -10813,7 +10813,7 @@
         </p:nvSpPr>
         <p:spPr>
           <a:xfrm>
-            <a:off x="566928" y="5332883"/>
+            <a:off x="566928" y="5349376"/>
             <a:ext cx="7452360" cy="384048"/>
           </a:xfrm>
           <a:prstGeom prst="rect">
@@ -10839,7 +10839,7 @@
                 </a:solidFill>
                 <a:latin typeface="Microsoft YaHei"/>
               </a:rPr>
-              <a:t>红线 = 二阶锥规划的精确解，与仿真轮次无关；蓝点 = 官方 K = 20000 的 S0（5.5412 flit/cycle，Jain 0.92818）。</a:t>
+              <a:t>红线 = 每个公平目标下的理论最高带宽；点 = 官方 K = 20000 实测。八个点依次覆盖 S0 / S1 / S1T / S16 / I-tag / S19 / S20 / S22。</a:t>
             </a:r>
           </a:p>
         </p:txBody>
@@ -10878,7 +10878,7 @@
                 </a:solidFill>
                 <a:latin typeface="Arial"/>
               </a:rPr>
-              <a:t>F O R M A L   D E R I V A T I O N</a:t>
+              <a:t>H O W   T O   R E A D   T H E   C U R V E</a:t>
             </a:r>
           </a:p>
         </p:txBody>
@@ -10892,7 +10892,7 @@
         <p:spPr>
           <a:xfrm>
             <a:off x="8403336" y="1408176"/>
-            <a:ext cx="3221431" cy="1834896"/>
+            <a:ext cx="3221431" cy="1473060"/>
           </a:xfrm>
           <a:prstGeom prst="rect">
             <a:avLst/>
@@ -10963,7 +10963,7 @@
                 </a:solidFill>
                 <a:latin typeface="Microsoft YaHei"/>
               </a:rPr>
-              <a:t>三个变量的含义</a:t>
+              <a:t>先认四个量</a:t>
             </a:r>
           </a:p>
         </p:txBody>
@@ -10977,7 +10977,7 @@
         <p:spPr>
           <a:xfrm>
             <a:off x="8586215" y="1932432"/>
-            <a:ext cx="2855671" cy="1475597"/>
+            <a:ext cx="2855671" cy="1172992"/>
           </a:xfrm>
           <a:prstGeom prst="rect">
             <a:avLst/>
@@ -11011,7 +11011,7 @@
                 </a:solidFill>
                 <a:latin typeface="Microsoft YaHei"/>
               </a:rPr>
-              <a:t>（决策变量）= 第 c 个核每拍发出多少笔事务。十个核 → 十个数。</a:t>
+              <a:t>：第 c 个核的事务速率；十个核就是十个待选择的速率。</a:t>
             </a:r>
           </a:p>
           <a:p>
@@ -11030,7 +11030,7 @@
                 </a:solidFill>
                 <a:latin typeface="Microsoft YaHei"/>
               </a:rPr>
-              <a:t>a(r,c)</a:t>
+              <a:t>链路占用表</a:t>
             </a:r>
             <a:r>
               <a:rPr sz="800" b="0">
@@ -11039,7 +11039,7 @@
                 </a:solidFill>
                 <a:latin typeface="Microsoft YaHei"/>
               </a:rPr>
-              <a:t> = 核 c 每发一笔事务，平均占用资源 r 多少拍。r 遍历每条（链路，方向，VC）。路由固定、握手固定，所以这是个常数表。</a:t>
+              <a:t>：每个核发一笔事务，会占哪些链路、各占几拍。路由和握手固定后，这张表也是固定的。</a:t>
             </a:r>
           </a:p>
           <a:p>
@@ -11058,7 +11058,7 @@
                 </a:solidFill>
                 <a:latin typeface="Microsoft YaHei"/>
               </a:rPr>
-              <a:t>约束 Σc a(r,c)·λc ≤ 1</a:t>
+              <a:t>J</a:t>
             </a:r>
             <a:r>
               <a:rPr sz="800" b="0">
@@ -11067,7 +11067,7 @@
                 </a:solidFill>
                 <a:latin typeface="Microsoft YaHei"/>
               </a:rPr>
-              <a:t> = 任何一条链路每拍最多搬 1 flit。</a:t>
+              <a:t>：本次要求的最低 Jain 公平度，例如 0.95。</a:t>
             </a:r>
           </a:p>
           <a:p>
@@ -11086,7 +11086,7 @@
                 </a:solidFill>
                 <a:latin typeface="Microsoft YaHei"/>
               </a:rPr>
-              <a:t>Jain(λ) ≥ J</a:t>
+              <a:t>R(J)</a:t>
             </a:r>
             <a:r>
               <a:rPr sz="800" b="0">
@@ -11095,25 +11095,7 @@
                 </a:solidFill>
                 <a:latin typeface="Microsoft YaHei"/>
               </a:rPr>
-              <a:t> ⟺ ‖λ‖₂ ≤ (Σλc)/√(J·10)：一个二阶锥约束，所以 R(J) = max Σλc 是</a:t>
-            </a:r>
-            <a:r>
-              <a:rPr sz="800" b="1">
-                <a:solidFill>
-                  <a:srgbClr val="20242C"/>
-                </a:solidFill>
-                <a:latin typeface="Microsoft YaHei"/>
-              </a:rPr>
-              <a:t>精确解</a:t>
-            </a:r>
-            <a:r>
-              <a:rPr sz="800" b="0">
-                <a:solidFill>
-                  <a:srgbClr val="20242C"/>
-                </a:solidFill>
-                <a:latin typeface="Microsoft YaHei"/>
-              </a:rPr>
-              <a:t>，不是估计。</a:t>
+              <a:t>：在公平度不低于 J 的前提下，所有核合计最多能跑多快。</a:t>
             </a:r>
           </a:p>
         </p:txBody>
@@ -11126,8 +11108,8 @@
         </p:nvSpPr>
         <p:spPr>
           <a:xfrm>
-            <a:off x="8403336" y="3389376"/>
-            <a:ext cx="3221431" cy="938784"/>
+            <a:off x="8403336" y="3027540"/>
+            <a:ext cx="3221431" cy="1043418"/>
           </a:xfrm>
           <a:prstGeom prst="rect">
             <a:avLst/>
@@ -11170,8 +11152,8 @@
         </p:nvSpPr>
         <p:spPr>
           <a:xfrm>
-            <a:off x="8714232" y="3480816"/>
-            <a:ext cx="2599639" cy="755904"/>
+            <a:off x="8714232" y="3118980"/>
+            <a:ext cx="2599639" cy="860538"/>
           </a:xfrm>
           <a:prstGeom prst="rect">
             <a:avLst/>
@@ -11190,13 +11172,13 @@
               </a:lnSpc>
             </a:pPr>
             <a:r>
-              <a:rPr sz="1200" b="0">
+              <a:rPr sz="1100" b="0">
                 <a:solidFill>
                   <a:srgbClr val="FFFFFF"/>
                 </a:solidFill>
                 <a:latin typeface="Microsoft YaHei"/>
               </a:rPr>
-              <a:t>① 完全等速率的上限 R* = 5.7143，无约束峰值 R_max = 6.4000 —— 公平的固有代价 −10.71%。</a:t>
+              <a:t>一个红线点怎么来：先固定 J，再尝试十个核的所有速率组合；任何链路都不能超过每拍 1 flit，最后保留总带宽最高的组合。</a:t>
             </a:r>
           </a:p>
         </p:txBody>
@@ -11209,8 +11191,8 @@
         </p:nvSpPr>
         <p:spPr>
           <a:xfrm>
-            <a:off x="8403336" y="4474464"/>
-            <a:ext cx="3221431" cy="853440"/>
+            <a:off x="8403336" y="4217262"/>
+            <a:ext cx="3221431" cy="941122"/>
           </a:xfrm>
           <a:prstGeom prst="rect">
             <a:avLst/>
@@ -11253,8 +11235,8 @@
         </p:nvSpPr>
         <p:spPr>
           <a:xfrm>
-            <a:off x="8714232" y="4565904"/>
-            <a:ext cx="2599639" cy="670560"/>
+            <a:off x="8714232" y="4308702"/>
+            <a:ext cx="2599639" cy="758242"/>
           </a:xfrm>
           <a:prstGeom prst="rect">
             <a:avLst/>
@@ -11279,7 +11261,7 @@
                 </a:solidFill>
                 <a:latin typeface="Microsoft YaHei"/>
               </a:rPr>
-              <a:t>② 曲线在高 Jain 段陡然变贵：最后 0.01 的 Jain 单价是前面一大段的 3.6 倍。</a:t>
+              <a:t>把 J 从低到高逐点重算，就得到整条红线。这是标准凸优化的全局上界（只有数值求解误差），不是对仿真点做拟合。</a:t>
             </a:r>
           </a:p>
         </p:txBody>
@@ -11292,8 +11274,8 @@
         </p:nvSpPr>
         <p:spPr>
           <a:xfrm>
-            <a:off x="8403336" y="5474208"/>
-            <a:ext cx="3221431" cy="853440"/>
+            <a:off x="8403336" y="5304689"/>
+            <a:ext cx="3221431" cy="1022958"/>
           </a:xfrm>
           <a:prstGeom prst="rect">
             <a:avLst/>
@@ -11336,8 +11318,8 @@
         </p:nvSpPr>
         <p:spPr>
           <a:xfrm>
-            <a:off x="8714232" y="5565647"/>
-            <a:ext cx="2599639" cy="670560"/>
+            <a:off x="8714232" y="5396129"/>
+            <a:ext cx="2599639" cy="840078"/>
           </a:xfrm>
           <a:prstGeom prst="rect">
             <a:avLst/>
@@ -11356,31 +11338,13 @@
               </a:lnSpc>
             </a:pPr>
             <a:r>
-              <a:rPr sz="1200" b="0">
+              <a:rPr sz="1050" b="0">
                 <a:solidFill>
                   <a:srgbClr val="FFFFFF"/>
                 </a:solidFill>
                 <a:latin typeface="Microsoft YaHei"/>
               </a:rPr>
-              <a:t>③ S0 实测落在曲线</a:t>
-            </a:r>
-            <a:r>
-              <a:rPr sz="1200" b="1">
-                <a:solidFill>
-                  <a:srgbClr val="FFFFFF"/>
-                </a:solidFill>
-                <a:latin typeface="Microsoft YaHei"/>
-              </a:rPr>
-              <a:t>下方</a:t>
-            </a:r>
-            <a:r>
-              <a:rPr sz="1200" b="0">
-                <a:solidFill>
-                  <a:srgbClr val="FFFFFF"/>
-                </a:solidFill>
-                <a:latin typeface="Microsoft YaHei"/>
-              </a:rPr>
-              <a:t>：它既不最快也不最公平，本身就不在前沿上。</a:t>
+              <a:t>读图：红线上 = 该公平度下理论能做到的最好结果；红线下 = 实际机制损失；红线上方 = 资源容量不允许。J = 1 的最右端就是等速率上限 R* = 5.7143。</a:t>
             </a:r>
           </a:p>
         </p:txBody>

</xml_diff>

<commit_message>
Refine the architecture conclusions and recommendations
Present the evidence chain more clearly, keep outstanding fixed by RTT coverage, and narrow the decision to S16 with S22 as the ring-only fallback.

Co-authored-by: Cursor <cursoragent@cursor.com>
</commit_message>
<xml_diff>
--- a/ppt/ring2-write-fairness.pptx
+++ b/ppt/ring2-write-fairness.pptx
@@ -14866,7 +14866,7 @@
                 </a:solidFill>
                 <a:latin typeface="Microsoft YaHei"/>
               </a:rPr>
-              <a:t>η =（总带宽 × 分箱 Jain）/ 理想控制器的同一乘积。理想 = 1.0。筛选轮 K = 2000，每核在飞上限 32，100 拍窗。</a:t>
+              <a:t>η =（总带宽 × 分箱 Jain）/ 理想控制器的同一乘积。理想 = 1.0。筛选轮 K = 2000，100 拍窗。</a:t>
             </a:r>
           </a:p>
         </p:txBody>
@@ -15235,7 +15235,7 @@
                 </a:solidFill>
                 <a:latin typeface="Microsoft YaHei"/>
               </a:rPr>
-              <a:t>S19 / S20（5,840，η 0.8992）与 S22-stock（13,920，η 0.8883）在成本—收益平面上被 S16 支配，但改动层次不同，仍是有意义的工程备选。</a:t>
+              <a:t>S22-stock（13,920，η 0.8883）保留为事务层不可改时的环仲裁备选；S19 / S20（5,840，η 0.8992）只作为 requester 窗口控制的研究对照。</a:t>
             </a:r>
           </a:p>
           <a:p>
@@ -16034,7 +16034,7 @@
                 </a:solidFill>
                 <a:latin typeface="Microsoft YaHei"/>
               </a:rPr>
-              <a:t>在飞上限收到 32 之后，S0 本身就已经拿到 R* 的 </a:t>
+              <a:t>固定实验配置下，S0 本身就已经拿到 R* 的 </a:t>
             </a:r>
             <a:r>
               <a:rPr sz="800" b="1">
@@ -16088,7 +16088,7 @@
                 </a:solidFill>
                 <a:latin typeface="Microsoft YaHei"/>
               </a:rPr>
-              <a:t>，E-tag 绕环从 4,384 降到 </a:t>
+              <a:t>，E-tag 绕环降到 </a:t>
             </a:r>
             <a:r>
               <a:rPr sz="800" b="1">
@@ -16610,7 +16610,7 @@
                 </a:solidFill>
                 <a:latin typeface="Microsoft YaHei"/>
               </a:rPr>
-              <a:t>四个方案、三种控制层次：机制示意 + 与 S0 / S1 的同口径实测对比。</a:t>
+              <a:t>两个落地候选、两个研究对照：机制示意 + 与 S0 / S1 的同口径实测。</a:t>
             </a:r>
           </a:p>
         </p:txBody>
@@ -16732,7 +16732,7 @@
                 </a:solidFill>
                 <a:latin typeface="Microsoft YaHei"/>
               </a:rPr>
-              <a:t>S16 是严格成本—收益前沿；S19、S20 与 S22 是改动层次不同的近前沿工程备选。四者都可实现、数据来自测量，且不含流量 pattern 先验。</a:t>
+              <a:t>S16 是主方案，S22 是事务层不可改时的环仲裁备选；S19 / S20 用于验证 requester 动态窗口的边界，不进入最终架构建议。</a:t>
             </a:r>
           </a:p>
         </p:txBody>
@@ -19047,13 +19047,13 @@
               </a:lnSpc>
             </a:pPr>
             <a:r>
-              <a:rPr sz="800" b="1">
+              <a:rPr sz="950" b="1">
                 <a:solidFill>
                   <a:srgbClr val="D20A2E"/>
                 </a:solidFill>
                 <a:latin typeface="Arial"/>
               </a:rPr>
-              <a:t>N E A R - F R O N T I E R   ·   W I N D O W   C C</a:t>
+              <a:t>R E F E R E N C E   ·   W I N D O W   C C</a:t>
             </a:r>
           </a:p>
         </p:txBody>
@@ -19965,8 +19965,8 @@
         </p:blipFill>
         <p:spPr>
           <a:xfrm>
-            <a:off x="3328416" y="1169399"/>
-            <a:ext cx="8296351" cy="2629125"/>
+            <a:off x="3526488" y="1024128"/>
+            <a:ext cx="7900206" cy="2503586"/>
           </a:xfrm>
           <a:prstGeom prst="rect">
             <a:avLst/>
@@ -19981,7 +19981,7 @@
         </p:nvSpPr>
         <p:spPr>
           <a:xfrm>
-            <a:off x="3328416" y="3889965"/>
+            <a:off x="3328416" y="3619154"/>
             <a:ext cx="8296351" cy="292608"/>
           </a:xfrm>
           <a:prstGeom prst="rect">
@@ -20020,8 +20020,8 @@
         </p:nvSpPr>
         <p:spPr>
           <a:xfrm>
-            <a:off x="566928" y="4657029"/>
-            <a:ext cx="3527450" cy="1670618"/>
+            <a:off x="566928" y="4240946"/>
+            <a:ext cx="3527450" cy="2086701"/>
           </a:xfrm>
           <a:prstGeom prst="rect">
             <a:avLst/>
@@ -20066,7 +20066,7 @@
         </p:nvSpPr>
         <p:spPr>
           <a:xfrm>
-            <a:off x="768096" y="5000317"/>
+            <a:off x="768096" y="4792276"/>
             <a:ext cx="3125114" cy="277622"/>
           </a:xfrm>
           <a:prstGeom prst="rect">
@@ -20105,7 +20105,7 @@
         </p:nvSpPr>
         <p:spPr>
           <a:xfrm>
-            <a:off x="768096" y="5360235"/>
+            <a:off x="768096" y="5152194"/>
             <a:ext cx="3125114" cy="660699"/>
           </a:xfrm>
           <a:prstGeom prst="rect">
@@ -20144,8 +20144,8 @@
         </p:nvSpPr>
         <p:spPr>
           <a:xfrm>
-            <a:off x="4332122" y="4657029"/>
-            <a:ext cx="3527450" cy="1670618"/>
+            <a:off x="4332122" y="4240946"/>
+            <a:ext cx="3527450" cy="2086701"/>
           </a:xfrm>
           <a:prstGeom prst="rect">
             <a:avLst/>
@@ -20190,7 +20190,7 @@
         </p:nvSpPr>
         <p:spPr>
           <a:xfrm>
-            <a:off x="4533290" y="4858197"/>
+            <a:off x="4533290" y="4650155"/>
             <a:ext cx="3125114" cy="277622"/>
           </a:xfrm>
           <a:prstGeom prst="rect">
@@ -20229,7 +20229,7 @@
         </p:nvSpPr>
         <p:spPr>
           <a:xfrm>
-            <a:off x="4533290" y="5218115"/>
+            <a:off x="4533290" y="5010073"/>
             <a:ext cx="3125114" cy="944940"/>
           </a:xfrm>
           <a:prstGeom prst="rect">
@@ -20305,8 +20305,8 @@
         </p:nvSpPr>
         <p:spPr>
           <a:xfrm>
-            <a:off x="8097316" y="4657029"/>
-            <a:ext cx="3527450" cy="1670618"/>
+            <a:off x="8097316" y="4240946"/>
+            <a:ext cx="3527450" cy="2086701"/>
           </a:xfrm>
           <a:prstGeom prst="rect">
             <a:avLst/>
@@ -20351,7 +20351,7 @@
         </p:nvSpPr>
         <p:spPr>
           <a:xfrm>
-            <a:off x="8298484" y="5000317"/>
+            <a:off x="8298484" y="4442114"/>
             <a:ext cx="3125114" cy="277622"/>
           </a:xfrm>
           <a:prstGeom prst="rect">
@@ -20377,7 +20377,7 @@
                 </a:solidFill>
                 <a:latin typeface="Microsoft YaHei"/>
               </a:rPr>
-              <a:t>工程选择</a:t>
+              <a:t>参考结论</a:t>
             </a:r>
           </a:p>
         </p:txBody>
@@ -20390,8 +20390,8 @@
         </p:nvSpPr>
         <p:spPr>
           <a:xfrm>
-            <a:off x="8298484" y="5360235"/>
-            <a:ext cx="3125114" cy="660699"/>
+            <a:off x="8298484" y="4802032"/>
+            <a:ext cx="3125114" cy="1361023"/>
           </a:xfrm>
           <a:prstGeom prst="rect">
             <a:avLst/>
@@ -20416,7 +20416,26 @@
                 </a:solidFill>
                 <a:latin typeface="Microsoft YaHei"/>
               </a:rPr>
-              <a:t>已经有 RTT 计时器时，S19 集成最轻；已经有 tracker 水位与可用标记位时，S20 的拥塞含义更明确。两者都涉及 requester 的事务发起窗口。</a:t>
+              <a:t>两者都基本保住总带宽，但 Jain 与长期速率差几乎没有离开 S0。这说明 requester 窗口能限制注入量，却没有把瓶颈 hop 的服务机会从快核搬给慢核。</a:t>
+            </a:r>
+          </a:p>
+          <a:p>
+            <a:pPr algn="l">
+              <a:lnSpc>
+                <a:spcPct val="102000"/>
+              </a:lnSpc>
+              <a:spcBef>
+                <a:spcPts val="600"/>
+              </a:spcBef>
+            </a:pPr>
+            <a:r>
+              <a:rPr sz="1100" b="1">
+                <a:solidFill>
+                  <a:srgbClr val="D20A2E"/>
+                </a:solidFill>
+                <a:latin typeface="Microsoft YaHei"/>
+              </a:rPr>
+              <a:t>仅保留为 source-side 控制对照，不进入最终架构建议。</a:t>
             </a:r>
           </a:p>
         </p:txBody>
@@ -22640,7 +22659,7 @@
                 </a:solidFill>
                 <a:latin typeface="Microsoft YaHei"/>
               </a:rPr>
-              <a:t>哪些已经关死，哪些还开着，以及下一步该由谁拍板。</a:t>
+              <a:t>从现象、根因、理论上界到可实现机制，形成完整证据闭环。</a:t>
             </a:r>
           </a:p>
         </p:txBody>
@@ -22762,7 +22781,7 @@
                 </a:solidFill>
                 <a:latin typeface="Microsoft YaHei"/>
               </a:rPr>
-              <a:t>带宽线已基本关死；公平缺陷是真实的，但它不必用带宽去换。真正要拍板的不是单一排名，而是哪一层能改：completer、requester，还是只允许动环上仲裁。</a:t>
+              <a:t>问题已经收敛为一个架构决策：能改 HA 授权调度就验证 S16；事务层不能改，则验证只动环上仲裁的 S22。</a:t>
             </a:r>
           </a:p>
         </p:txBody>
@@ -23657,7 +23676,7 @@
                 </a:solidFill>
                 <a:latin typeface="Microsoft YaHei"/>
               </a:rPr>
-              <a:t>四条</a:t>
+              <a:t>三项确定结论 + 一个架构决策</a:t>
             </a:r>
           </a:p>
         </p:txBody>
@@ -23670,8 +23689,8 @@
         </p:nvSpPr>
         <p:spPr>
           <a:xfrm>
-            <a:off x="566928" y="2231136"/>
-            <a:ext cx="2599867" cy="2999231"/>
+            <a:off x="566928" y="2233589"/>
+            <a:ext cx="2599867" cy="2994324"/>
           </a:xfrm>
           <a:prstGeom prst="rect">
             <a:avLst/>
@@ -23716,7 +23735,7 @@
         </p:nvSpPr>
         <p:spPr>
           <a:xfrm>
-            <a:off x="768096" y="2813288"/>
+            <a:off x="768096" y="2699811"/>
             <a:ext cx="2197531" cy="314705"/>
           </a:xfrm>
           <a:prstGeom prst="rect">
@@ -23742,7 +23761,7 @@
                 </a:solidFill>
                 <a:latin typeface="Microsoft YaHei"/>
               </a:rPr>
-              <a:t>① 带宽线已基本关死</a:t>
+              <a:t>① 容量问题已闭环</a:t>
             </a:r>
           </a:p>
         </p:txBody>
@@ -23755,8 +23774,8 @@
         </p:nvSpPr>
         <p:spPr>
           <a:xfrm>
-            <a:off x="768096" y="3210290"/>
-            <a:ext cx="2197531" cy="1474500"/>
+            <a:off x="768096" y="3096813"/>
+            <a:ext cx="2197531" cy="1701454"/>
           </a:xfrm>
           <a:prstGeom prst="rect">
             <a:avLst/>
@@ -23781,7 +23800,7 @@
                 </a:solidFill>
                 <a:latin typeface="Microsoft YaHei"/>
               </a:rPr>
-              <a:t>S0 = 96.97% R*，最忙的链路 96.98% 满；3.03% 的缺口已逐拍闭合（5 拍绕环 + 2,181 拍空转）。</a:t>
+              <a:t>S0 最忙链路利用率 96.98%；相对 R* 的 3.03% 缺口已按拍拆成有效载荷、绕环重发和四类空转，账目无残项。</a:t>
             </a:r>
           </a:p>
           <a:p>
@@ -23800,7 +23819,7 @@
                 </a:solidFill>
                 <a:latin typeface="Microsoft YaHei"/>
               </a:rPr>
-              <a:t>拥塞控制的带宽目标应是「不弄丢」，不是「抬上去」。</a:t>
+              <a:t>结论：当前问题不是带宽没打满，而是满载时服务机会分配不均。</a:t>
             </a:r>
           </a:p>
         </p:txBody>
@@ -23813,8 +23832,8 @@
         </p:nvSpPr>
         <p:spPr>
           <a:xfrm>
-            <a:off x="3386251" y="2231136"/>
-            <a:ext cx="2599867" cy="2999231"/>
+            <a:off x="3386251" y="2233589"/>
+            <a:ext cx="2599867" cy="2994324"/>
           </a:xfrm>
           <a:prstGeom prst="rect">
             <a:avLst/>
@@ -23885,7 +23904,7 @@
                 </a:solidFill>
                 <a:latin typeface="Microsoft YaHei"/>
               </a:rPr>
-              <a:t>② 公平缺陷是真实的</a:t>
+              <a:t>② 公平性是结构问题</a:t>
             </a:r>
           </a:p>
         </p:txBody>
@@ -23924,7 +23943,7 @@
                 </a:solidFill>
                 <a:latin typeface="Microsoft YaHei"/>
               </a:rPr>
-              <a:t>不是采样噪声：把抖动完全抹平后的 Jain 上限只有 0.96458，六快四慢是几何决定的固定分组（核间速率比 1.5673）。</a:t>
+              <a:t>六快四慢随时间稳定存在；即使完全抹平瞬时抖动，Jain 上限仍只有 0.96458，核间长期速率比为 1.5673。</a:t>
             </a:r>
           </a:p>
           <a:p>
@@ -23943,7 +23962,7 @@
                 </a:solidFill>
                 <a:latin typeface="Microsoft YaHei"/>
               </a:rPr>
-              <a:t>要提高均衡度就必须真的搬速率，只整时机不够。</a:t>
+              <a:t>结论：只整形发包时机不够，必须在瓶颈处重新分配服务机会。</a:t>
             </a:r>
           </a:p>
         </p:txBody>
@@ -23956,8 +23975,8 @@
         </p:nvSpPr>
         <p:spPr>
           <a:xfrm>
-            <a:off x="6205575" y="2231136"/>
-            <a:ext cx="2599867" cy="2999231"/>
+            <a:off x="6205575" y="2233589"/>
+            <a:ext cx="2599867" cy="2994324"/>
           </a:xfrm>
           <a:prstGeom prst="rect">
             <a:avLst/>
@@ -24002,8 +24021,8 @@
         </p:nvSpPr>
         <p:spPr>
           <a:xfrm>
-            <a:off x="6406743" y="2560746"/>
-            <a:ext cx="2197531" cy="592836"/>
+            <a:off x="6406743" y="2586334"/>
+            <a:ext cx="2197531" cy="314705"/>
           </a:xfrm>
           <a:prstGeom prst="rect">
             <a:avLst/>
@@ -24028,7 +24047,7 @@
                 </a:solidFill>
                 <a:latin typeface="Microsoft YaHei"/>
               </a:rPr>
-              <a:t>③ 严格前沿与工程备选要分开看</a:t>
+              <a:t>③ 上界与评价口径已建立</a:t>
             </a:r>
           </a:p>
         </p:txBody>
@@ -24041,8 +24060,8 @@
         </p:nvSpPr>
         <p:spPr>
           <a:xfrm>
-            <a:off x="6406743" y="3235878"/>
-            <a:ext cx="2197531" cy="1701454"/>
+            <a:off x="6406743" y="2983336"/>
+            <a:ext cx="2197531" cy="1928408"/>
           </a:xfrm>
           <a:prstGeom prst="rect">
             <a:avLst/>
@@ -24067,7 +24086,7 @@
                 </a:solidFill>
                 <a:latin typeface="Microsoft YaHei"/>
               </a:rPr>
-              <a:t>按「带宽 × 公平性 / 硬件」计算，严格前沿是 S16。S19 / S20、S22 虽不在严格前沿上，但分别落在 requester 动态窗口和跨节点进度仲裁两个不同改动层。</a:t>
+              <a:t>由逐链路占用约束求得 R(J) 理论边界与等速率上限 R* = 5.7143；再用 100 拍 Jain、长期 max/min、硬件 FF‑eq 和流量迁移统一评估。</a:t>
             </a:r>
           </a:p>
           <a:p>
@@ -24086,7 +24105,7 @@
                 </a:solidFill>
                 <a:latin typeface="Microsoft YaHei"/>
               </a:rPr>
-              <a:t>被数值支配，不等于在工程约束下没有选择价值。</a:t>
+              <a:t>结论：方案优劣来自同一上界下的可量化差距，不依赖经验判断。</a:t>
             </a:r>
           </a:p>
         </p:txBody>
@@ -24099,8 +24118,8 @@
         </p:nvSpPr>
         <p:spPr>
           <a:xfrm>
-            <a:off x="9024899" y="2231136"/>
-            <a:ext cx="2599867" cy="2999231"/>
+            <a:off x="9024899" y="2233589"/>
+            <a:ext cx="2599867" cy="2994324"/>
           </a:xfrm>
           <a:prstGeom prst="rect">
             <a:avLst/>
@@ -24145,8 +24164,8 @@
         </p:nvSpPr>
         <p:spPr>
           <a:xfrm>
-            <a:off x="9226067" y="2465908"/>
-            <a:ext cx="2197531" cy="592836"/>
+            <a:off x="9226067" y="2434757"/>
+            <a:ext cx="2197531" cy="314705"/>
           </a:xfrm>
           <a:prstGeom prst="rect">
             <a:avLst/>
@@ -24171,7 +24190,7 @@
                 </a:solidFill>
                 <a:latin typeface="Microsoft YaHei"/>
               </a:rPr>
-              <a:t>④ 两头能同时拿住，但层次决定落点</a:t>
+              <a:t>④ 控制点决定方案</a:t>
             </a:r>
           </a:p>
         </p:txBody>
@@ -24184,8 +24203,8 @@
         </p:nvSpPr>
         <p:spPr>
           <a:xfrm>
-            <a:off x="9226067" y="3141040"/>
-            <a:ext cx="2197531" cy="1891131"/>
+            <a:off x="9226067" y="2831759"/>
+            <a:ext cx="2197531" cy="2231562"/>
           </a:xfrm>
           <a:prstGeom prst="rect">
             <a:avLst/>
@@ -24204,13 +24223,13 @@
               </a:lnSpc>
             </a:pPr>
             <a:r>
-              <a:rPr sz="1000" b="0">
-                <a:solidFill>
-                  <a:srgbClr val="20242C"/>
-                </a:solidFill>
-                <a:latin typeface="Microsoft YaHei"/>
-              </a:rPr>
-              <a:t>S16 把决策点放回 completer：Jain 0.92818 → 0.98466，max/min → 1.0001，带宽只让 0.39%，硬件 900 FF‑eq。</a:t>
+              <a:rPr sz="1200" b="0">
+                <a:solidFill>
+                  <a:srgbClr val="20242C"/>
+                </a:solidFill>
+                <a:latin typeface="Microsoft YaHei"/>
+              </a:rPr>
+              <a:t>S16 在 HA 授权点直接重排服务：900 FF‑eq，Jain 0.98466，max/min 1.0001，总带宽仅 −0.39%。</a:t>
             </a:r>
           </a:p>
           <a:p>
@@ -24223,13 +24242,13 @@
               </a:spcBef>
             </a:pPr>
             <a:r>
-              <a:rPr sz="1000" b="0">
-                <a:solidFill>
-                  <a:srgbClr val="20242C"/>
-                </a:solidFill>
-                <a:latin typeface="Microsoft YaHei"/>
-              </a:rPr>
-              <a:t>它需要改 HA 的授权调度。若该层不可改，可退到 requester 窗口S19 / S20，或只改环上仲裁的 S22。</a:t>
+              <a:rPr sz="1200" b="0">
+                <a:solidFill>
+                  <a:srgbClr val="20242C"/>
+                </a:solidFill>
+                <a:latin typeface="Microsoft YaHei"/>
+              </a:rPr>
+              <a:t>若事务层不可改，S22 是只动环仲裁的备选；S19 / S20 仅作对照。</a:t>
             </a:r>
           </a:p>
           <a:p>
@@ -24242,13 +24261,13 @@
               </a:spcBef>
             </a:pPr>
             <a:r>
-              <a:rPr sz="1000" b="1">
+              <a:rPr sz="1200" b="1">
                 <a:solidFill>
                   <a:srgbClr val="D20A2E"/>
                 </a:solidFill>
                 <a:latin typeface="Microsoft YaHei"/>
               </a:rPr>
-              <a:t>最终选择首先由「哪一层能改」决定，其次才是数字。</a:t>
+              <a:t>架构决策只剩：HA 授权调度能不能改。</a:t>
             </a:r>
           </a:p>
         </p:txBody>
@@ -24331,7 +24350,7 @@
                 </a:solidFill>
                 <a:latin typeface="Microsoft YaHei"/>
               </a:rPr>
-              <a:t>统一结论：不要把所有机制压成一个排名。S16、S19 / S20、S22 分别交换 completer、requester、跨节点仲裁的改动权限；先确定可改边界，再在对应层内选性能最好的方案。</a:t>
+              <a:t>本研究完成了「现象复现 → 逐拍归因 → 理论上界 → 机制设计 → 硬件代价 → 流量迁移」闭环，并把开放问题压缩为一项可决策的架构边界。</a:t>
             </a:r>
           </a:p>
         </p:txBody>
@@ -24720,7 +24739,7 @@
                 </a:solidFill>
                 <a:latin typeface="Microsoft YaHei"/>
               </a:rPr>
-              <a:t>先收在飞，再按可改层次选择</a:t>
+              <a:t>只保留一主一备，明确研究边界</a:t>
             </a:r>
           </a:p>
         </p:txBody>
@@ -24734,7 +24753,279 @@
         <p:spPr>
           <a:xfrm>
             <a:off x="566928" y="2194560"/>
-            <a:ext cx="2599867" cy="3017520"/>
+            <a:ext cx="3539642" cy="3017520"/>
+          </a:xfrm>
+          <a:prstGeom prst="rect">
+            <a:avLst/>
+          </a:prstGeom>
+          <a:solidFill>
+            <a:srgbClr val="FFFFFF"/>
+          </a:solidFill>
+          <a:ln w="19050">
+            <a:solidFill>
+              <a:srgbClr val="D20A2E"/>
+            </a:solidFill>
+          </a:ln>
+          <a:effectLst/>
+        </p:spPr>
+        <p:style>
+          <a:lnRef idx="1">
+            <a:schemeClr val="accent1"/>
+          </a:lnRef>
+          <a:fillRef idx="3">
+            <a:schemeClr val="accent1"/>
+          </a:fillRef>
+          <a:effectRef idx="2">
+            <a:schemeClr val="accent1"/>
+          </a:effectRef>
+          <a:fontRef idx="minor">
+            <a:schemeClr val="lt1"/>
+          </a:fontRef>
+        </p:style>
+        <p:txBody>
+          <a:bodyPr rtlCol="0" anchor="ctr" wrap="square"/>
+          <a:lstStyle/>
+          <a:p>
+            <a:pPr algn="ctr"/>
+          </a:p>
+        </p:txBody>
+      </p:sp>
+      <p:sp>
+        <p:nvSpPr>
+          <p:cNvPr id="11" name="Oval 10"/>
+          <p:cNvSpPr/>
+          <p:nvPr/>
+        </p:nvSpPr>
+        <p:spPr>
+          <a:xfrm>
+            <a:off x="786384" y="2414016"/>
+            <a:ext cx="384048" cy="384048"/>
+          </a:xfrm>
+          <a:prstGeom prst="ellipse">
+            <a:avLst/>
+          </a:prstGeom>
+          <a:solidFill>
+            <a:srgbClr val="D20A2E"/>
+          </a:solidFill>
+          <a:ln>
+            <a:noFill/>
+          </a:ln>
+          <a:effectLst/>
+        </p:spPr>
+        <p:style>
+          <a:lnRef idx="1">
+            <a:schemeClr val="accent1"/>
+          </a:lnRef>
+          <a:fillRef idx="3">
+            <a:schemeClr val="accent1"/>
+          </a:fillRef>
+          <a:effectRef idx="2">
+            <a:schemeClr val="accent1"/>
+          </a:effectRef>
+          <a:fontRef idx="minor">
+            <a:schemeClr val="lt1"/>
+          </a:fontRef>
+        </p:style>
+        <p:txBody>
+          <a:bodyPr rtlCol="0" anchor="ctr" wrap="square"/>
+          <a:lstStyle/>
+          <a:p>
+            <a:pPr algn="ctr"/>
+          </a:p>
+        </p:txBody>
+      </p:sp>
+      <p:sp>
+        <p:nvSpPr>
+          <p:cNvPr id="12" name="TextBox 11"/>
+          <p:cNvSpPr txBox="1"/>
+          <p:nvPr/>
+        </p:nvSpPr>
+        <p:spPr>
+          <a:xfrm>
+            <a:off x="786384" y="2496312"/>
+            <a:ext cx="384048" cy="237744"/>
+          </a:xfrm>
+          <a:prstGeom prst="rect">
+            <a:avLst/>
+          </a:prstGeom>
+          <a:noFill/>
+        </p:spPr>
+        <p:txBody>
+          <a:bodyPr wrap="square" anchor="t" lIns="0" rIns="0" tIns="0" bIns="0">
+            <a:spAutoFit/>
+          </a:bodyPr>
+          <a:lstStyle/>
+          <a:p>
+            <a:pPr algn="ctr">
+              <a:lnSpc>
+                <a:spcPct val="100000"/>
+              </a:lnSpc>
+            </a:pPr>
+            <a:r>
+              <a:rPr sz="1150" b="1">
+                <a:solidFill>
+                  <a:srgbClr val="FFFFFF"/>
+                </a:solidFill>
+                <a:latin typeface="Arial"/>
+              </a:rPr>
+              <a:t>01</a:t>
+            </a:r>
+          </a:p>
+        </p:txBody>
+      </p:sp>
+      <p:sp>
+        <p:nvSpPr>
+          <p:cNvPr id="13" name="TextBox 12"/>
+          <p:cNvSpPr txBox="1"/>
+          <p:nvPr/>
+        </p:nvSpPr>
+        <p:spPr>
+          <a:xfrm>
+            <a:off x="786384" y="2965650"/>
+            <a:ext cx="3100730" cy="314705"/>
+          </a:xfrm>
+          <a:prstGeom prst="rect">
+            <a:avLst/>
+          </a:prstGeom>
+          <a:noFill/>
+        </p:spPr>
+        <p:txBody>
+          <a:bodyPr wrap="square" anchor="t" lIns="0" rIns="0" tIns="0" bIns="0">
+            <a:spAutoFit/>
+          </a:bodyPr>
+          <a:lstStyle/>
+          <a:p>
+            <a:pPr algn="l">
+              <a:lnSpc>
+                <a:spcPct val="100000"/>
+              </a:lnSpc>
+            </a:pPr>
+            <a:r>
+              <a:rPr sz="1500" b="1">
+                <a:solidFill>
+                  <a:srgbClr val="D20A2E"/>
+                </a:solidFill>
+                <a:latin typeface="Microsoft YaHei"/>
+              </a:rPr>
+              <a:t>主方案 · S16 写侧授权保留</a:t>
+            </a:r>
+          </a:p>
+        </p:txBody>
+      </p:sp>
+      <p:sp>
+        <p:nvSpPr>
+          <p:cNvPr id="14" name="TextBox 13"/>
+          <p:cNvSpPr txBox="1"/>
+          <p:nvPr/>
+        </p:nvSpPr>
+        <p:spPr>
+          <a:xfrm>
+            <a:off x="786384" y="3362652"/>
+            <a:ext cx="3100730" cy="1645264"/>
+          </a:xfrm>
+          <a:prstGeom prst="rect">
+            <a:avLst/>
+          </a:prstGeom>
+          <a:noFill/>
+        </p:spPr>
+        <p:txBody>
+          <a:bodyPr wrap="square" anchor="t" lIns="0" rIns="0" tIns="0" bIns="0">
+            <a:spAutoFit/>
+          </a:bodyPr>
+          <a:lstStyle/>
+          <a:p>
+            <a:pPr algn="l">
+              <a:lnSpc>
+                <a:spcPct val="102000"/>
+              </a:lnSpc>
+            </a:pPr>
+            <a:r>
+              <a:rPr sz="1100" b="1">
+                <a:solidFill>
+                  <a:srgbClr val="20242C"/>
+                </a:solidFill>
+                <a:latin typeface="Microsoft YaHei"/>
+              </a:rPr>
+              <a:t>目标</a:t>
+            </a:r>
+            <a:r>
+              <a:rPr sz="1100" b="0">
+                <a:solidFill>
+                  <a:srgbClr val="20242C"/>
+                </a:solidFill>
+                <a:latin typeface="Microsoft YaHei"/>
+              </a:rPr>
+              <a:t>：在 HA / memory controller 内验证 DBIDResp 授权排队与最少服务优先。</a:t>
+            </a:r>
+          </a:p>
+          <a:p>
+            <a:pPr algn="l">
+              <a:lnSpc>
+                <a:spcPct val="102000"/>
+              </a:lnSpc>
+              <a:spcBef>
+                <a:spcPts val="600"/>
+              </a:spcBef>
+            </a:pPr>
+            <a:r>
+              <a:rPr sz="1100" b="1">
+                <a:solidFill>
+                  <a:srgbClr val="20242C"/>
+                </a:solidFill>
+                <a:latin typeface="Microsoft YaHei"/>
+              </a:rPr>
+              <a:t>价值</a:t>
+            </a:r>
+            <a:r>
+              <a:rPr sz="1100" b="0">
+                <a:solidFill>
+                  <a:srgbClr val="20242C"/>
+                </a:solidFill>
+                <a:latin typeface="Microsoft YaHei"/>
+              </a:rPr>
+              <a:t>：当前所有可实现点里，S16 离理论上界最近、硬件代价最低，并在 uniform / hot 两类流量下都不显著损失带宽。</a:t>
+            </a:r>
+          </a:p>
+          <a:p>
+            <a:pPr algn="l">
+              <a:lnSpc>
+                <a:spcPct val="102000"/>
+              </a:lnSpc>
+              <a:spcBef>
+                <a:spcPts val="600"/>
+              </a:spcBef>
+            </a:pPr>
+            <a:r>
+              <a:rPr sz="1100" b="1">
+                <a:solidFill>
+                  <a:srgbClr val="20242C"/>
+                </a:solidFill>
+                <a:latin typeface="Microsoft YaHei"/>
+              </a:rPr>
+              <a:t>门槛</a:t>
+            </a:r>
+            <a:r>
+              <a:rPr sz="1100" b="0">
+                <a:solidFill>
+                  <a:srgbClr val="20242C"/>
+                </a:solidFill>
+                <a:latin typeface="Microsoft YaHei"/>
+              </a:rPr>
+              <a:t>：确认 HA 授权时序、CHI 合规性和现有 tracker 接口可支持。</a:t>
+            </a:r>
+          </a:p>
+        </p:txBody>
+      </p:sp>
+      <p:sp>
+        <p:nvSpPr>
+          <p:cNvPr id="15" name="Rectangle 14"/>
+          <p:cNvSpPr/>
+          <p:nvPr/>
+        </p:nvSpPr>
+        <p:spPr>
+          <a:xfrm>
+            <a:off x="4326026" y="2194560"/>
+            <a:ext cx="3539642" cy="3017520"/>
           </a:xfrm>
           <a:prstGeom prst="rect">
             <a:avLst/>
@@ -24773,13 +25064,13 @@
       </p:sp>
       <p:sp>
         <p:nvSpPr>
-          <p:cNvPr id="11" name="Oval 10"/>
+          <p:cNvPr id="16" name="Oval 15"/>
           <p:cNvSpPr/>
           <p:nvPr/>
         </p:nvSpPr>
         <p:spPr>
           <a:xfrm>
-            <a:off x="786384" y="2414016"/>
+            <a:off x="4545482" y="2414016"/>
             <a:ext cx="384048" cy="384048"/>
           </a:xfrm>
           <a:prstGeom prst="ellipse">
@@ -24817,13 +25108,13 @@
       </p:sp>
       <p:sp>
         <p:nvSpPr>
-          <p:cNvPr id="12" name="TextBox 11"/>
-          <p:cNvSpPr txBox="1"/>
-          <p:nvPr/>
-        </p:nvSpPr>
-        <p:spPr>
-          <a:xfrm>
-            <a:off x="786384" y="2496312"/>
+          <p:cNvPr id="17" name="TextBox 16"/>
+          <p:cNvSpPr txBox="1"/>
+          <p:nvPr/>
+        </p:nvSpPr>
+        <p:spPr>
+          <a:xfrm>
+            <a:off x="4545482" y="2496312"/>
             <a:ext cx="384048" cy="237744"/>
           </a:xfrm>
           <a:prstGeom prst="rect">
@@ -24849,21 +25140,21 @@
                 </a:solidFill>
                 <a:latin typeface="Arial"/>
               </a:rPr>
-              <a:t>01</a:t>
-            </a:r>
-          </a:p>
-        </p:txBody>
-      </p:sp>
-      <p:sp>
-        <p:nvSpPr>
-          <p:cNvPr id="13" name="TextBox 12"/>
-          <p:cNvSpPr txBox="1"/>
-          <p:nvPr/>
-        </p:nvSpPr>
-        <p:spPr>
-          <a:xfrm>
-            <a:off x="786384" y="2968706"/>
-            <a:ext cx="2160955" cy="592836"/>
+              <a:t>02</a:t>
+            </a:r>
+          </a:p>
+        </p:txBody>
+      </p:sp>
+      <p:sp>
+        <p:nvSpPr>
+          <p:cNvPr id="18" name="TextBox 17"/>
+          <p:cNvSpPr txBox="1"/>
+          <p:nvPr/>
+        </p:nvSpPr>
+        <p:spPr>
+          <a:xfrm>
+            <a:off x="4545482" y="3150050"/>
+            <a:ext cx="3100730" cy="314705"/>
           </a:xfrm>
           <a:prstGeom prst="rect">
             <a:avLst/>
@@ -24888,21 +25179,21 @@
                 </a:solidFill>
                 <a:latin typeface="Microsoft YaHei"/>
               </a:rPr>
-              <a:t>第一步 · 0 FF‑eq · 无条件</a:t>
-            </a:r>
-          </a:p>
-        </p:txBody>
-      </p:sp>
-      <p:sp>
-        <p:nvSpPr>
-          <p:cNvPr id="14" name="TextBox 13"/>
-          <p:cNvSpPr txBox="1"/>
-          <p:nvPr/>
-        </p:nvSpPr>
-        <p:spPr>
-          <a:xfrm>
-            <a:off x="786384" y="3643838"/>
-            <a:ext cx="2160955" cy="1361023"/>
+              <a:t>备选 · S22 环上赤字让路</a:t>
+            </a:r>
+          </a:p>
+        </p:txBody>
+      </p:sp>
+      <p:sp>
+        <p:nvSpPr>
+          <p:cNvPr id="19" name="TextBox 18"/>
+          <p:cNvSpPr txBox="1"/>
+          <p:nvPr/>
+        </p:nvSpPr>
+        <p:spPr>
+          <a:xfrm>
+            <a:off x="4545482" y="3547052"/>
+            <a:ext cx="3100730" cy="1276464"/>
           </a:xfrm>
           <a:prstGeom prst="rect">
             <a:avLst/>
@@ -24921,22 +25212,22 @@
               </a:lnSpc>
             </a:pPr>
             <a:r>
-              <a:rPr sz="1100" b="1">
-                <a:solidFill>
-                  <a:srgbClr val="20242C"/>
-                </a:solidFill>
-                <a:latin typeface="Microsoft YaHei"/>
-              </a:rPr>
-              <a:t>每核在飞上限收到 32。</a:t>
-            </a:r>
-            <a:r>
-              <a:rPr sz="1100" b="0">
-                <a:solidFill>
-                  <a:srgbClr val="20242C"/>
-                </a:solidFill>
-                <a:latin typeface="Microsoft YaHei"/>
-              </a:rPr>
-              <a:t>零硬件、无流量先验：覆盖最坏 89 拍 RTT 只需约 26 笔，再多就只是在已经饱和的环上排队。</a:t>
+              <a:rPr sz="1150" b="1">
+                <a:solidFill>
+                  <a:srgbClr val="20242C"/>
+                </a:solidFill>
+                <a:latin typeface="Microsoft YaHei"/>
+              </a:rPr>
+              <a:t>适用条件</a:t>
+            </a:r>
+            <a:r>
+              <a:rPr sz="1150" b="0">
+                <a:solidFill>
+                  <a:srgbClr val="20242C"/>
+                </a:solidFill>
+                <a:latin typeface="Microsoft YaHei"/>
+              </a:rPr>
+              <a:t>：HA 事务调度不可改，但允许调整 ring arbitration。</a:t>
             </a:r>
           </a:p>
           <a:p>
@@ -24949,229 +25240,22 @@
               </a:spcBef>
             </a:pPr>
             <a:r>
-              <a:rPr sz="1100" b="1">
-                <a:solidFill>
-                  <a:srgbClr val="D20A2E"/>
-                </a:solidFill>
-                <a:latin typeface="Microsoft YaHei"/>
-              </a:rPr>
-              <a:t>uniform 绕环重发从上千拍降到 5 拍；非均匀流量带宽 +33%。</a:t>
-            </a:r>
-          </a:p>
-        </p:txBody>
-      </p:sp>
-      <p:sp>
-        <p:nvSpPr>
-          <p:cNvPr id="15" name="Rectangle 14"/>
-          <p:cNvSpPr/>
-          <p:nvPr/>
-        </p:nvSpPr>
-        <p:spPr>
-          <a:xfrm>
-            <a:off x="3386251" y="2194560"/>
-            <a:ext cx="2599867" cy="3017520"/>
-          </a:xfrm>
-          <a:prstGeom prst="rect">
-            <a:avLst/>
-          </a:prstGeom>
-          <a:solidFill>
-            <a:srgbClr val="FFFFFF"/>
-          </a:solidFill>
-          <a:ln w="19050">
-            <a:solidFill>
-              <a:srgbClr val="D20A2E"/>
-            </a:solidFill>
-          </a:ln>
-          <a:effectLst/>
-        </p:spPr>
-        <p:style>
-          <a:lnRef idx="1">
-            <a:schemeClr val="accent1"/>
-          </a:lnRef>
-          <a:fillRef idx="3">
-            <a:schemeClr val="accent1"/>
-          </a:fillRef>
-          <a:effectRef idx="2">
-            <a:schemeClr val="accent1"/>
-          </a:effectRef>
-          <a:fontRef idx="minor">
-            <a:schemeClr val="lt1"/>
-          </a:fontRef>
-        </p:style>
-        <p:txBody>
-          <a:bodyPr rtlCol="0" anchor="ctr" wrap="square"/>
-          <a:lstStyle/>
-          <a:p>
-            <a:pPr algn="ctr"/>
-          </a:p>
-        </p:txBody>
-      </p:sp>
-      <p:sp>
-        <p:nvSpPr>
-          <p:cNvPr id="16" name="Oval 15"/>
-          <p:cNvSpPr/>
-          <p:nvPr/>
-        </p:nvSpPr>
-        <p:spPr>
-          <a:xfrm>
-            <a:off x="3605707" y="2414016"/>
-            <a:ext cx="384048" cy="384048"/>
-          </a:xfrm>
-          <a:prstGeom prst="ellipse">
-            <a:avLst/>
-          </a:prstGeom>
-          <a:solidFill>
-            <a:srgbClr val="D20A2E"/>
-          </a:solidFill>
-          <a:ln>
-            <a:noFill/>
-          </a:ln>
-          <a:effectLst/>
-        </p:spPr>
-        <p:style>
-          <a:lnRef idx="1">
-            <a:schemeClr val="accent1"/>
-          </a:lnRef>
-          <a:fillRef idx="3">
-            <a:schemeClr val="accent1"/>
-          </a:fillRef>
-          <a:effectRef idx="2">
-            <a:schemeClr val="accent1"/>
-          </a:effectRef>
-          <a:fontRef idx="minor">
-            <a:schemeClr val="lt1"/>
-          </a:fontRef>
-        </p:style>
-        <p:txBody>
-          <a:bodyPr rtlCol="0" anchor="ctr" wrap="square"/>
-          <a:lstStyle/>
-          <a:p>
-            <a:pPr algn="ctr"/>
-          </a:p>
-        </p:txBody>
-      </p:sp>
-      <p:sp>
-        <p:nvSpPr>
-          <p:cNvPr id="17" name="TextBox 16"/>
-          <p:cNvSpPr txBox="1"/>
-          <p:nvPr/>
-        </p:nvSpPr>
-        <p:spPr>
-          <a:xfrm>
-            <a:off x="3605707" y="2496312"/>
-            <a:ext cx="384048" cy="237744"/>
-          </a:xfrm>
-          <a:prstGeom prst="rect">
-            <a:avLst/>
-          </a:prstGeom>
-          <a:noFill/>
-        </p:spPr>
-        <p:txBody>
-          <a:bodyPr wrap="square" anchor="t" lIns="0" rIns="0" tIns="0" bIns="0">
-            <a:spAutoFit/>
-          </a:bodyPr>
-          <a:lstStyle/>
-          <a:p>
-            <a:pPr algn="ctr">
-              <a:lnSpc>
-                <a:spcPct val="100000"/>
-              </a:lnSpc>
-            </a:pPr>
-            <a:r>
               <a:rPr sz="1150" b="1">
                 <a:solidFill>
-                  <a:srgbClr val="FFFFFF"/>
-                </a:solidFill>
-                <a:latin typeface="Arial"/>
-              </a:rPr>
-              <a:t>02</a:t>
-            </a:r>
-          </a:p>
-        </p:txBody>
-      </p:sp>
-      <p:sp>
-        <p:nvSpPr>
-          <p:cNvPr id="18" name="TextBox 17"/>
-          <p:cNvSpPr txBox="1"/>
-          <p:nvPr/>
-        </p:nvSpPr>
-        <p:spPr>
-          <a:xfrm>
-            <a:off x="3605707" y="2963978"/>
-            <a:ext cx="2160955" cy="592836"/>
-          </a:xfrm>
-          <a:prstGeom prst="rect">
-            <a:avLst/>
-          </a:prstGeom>
-          <a:noFill/>
-        </p:spPr>
-        <p:txBody>
-          <a:bodyPr wrap="square" anchor="t" lIns="0" rIns="0" tIns="0" bIns="0">
-            <a:spAutoFit/>
-          </a:bodyPr>
-          <a:lstStyle/>
-          <a:p>
-            <a:pPr algn="l">
-              <a:lnSpc>
-                <a:spcPct val="100000"/>
-              </a:lnSpc>
-            </a:pPr>
-            <a:r>
-              <a:rPr sz="1500" b="1">
-                <a:solidFill>
-                  <a:srgbClr val="D20A2E"/>
-                </a:solidFill>
-                <a:latin typeface="Microsoft YaHei"/>
-              </a:rPr>
-              <a:t>completer 可改 · 900 FF‑eq</a:t>
-            </a:r>
-          </a:p>
-        </p:txBody>
-      </p:sp>
-      <p:sp>
-        <p:nvSpPr>
-          <p:cNvPr id="19" name="TextBox 18"/>
-          <p:cNvSpPr txBox="1"/>
-          <p:nvPr/>
-        </p:nvSpPr>
-        <p:spPr>
-          <a:xfrm>
-            <a:off x="3605707" y="3639110"/>
-            <a:ext cx="2160955" cy="1370479"/>
-          </a:xfrm>
-          <a:prstGeom prst="rect">
-            <a:avLst/>
-          </a:prstGeom>
-          <a:noFill/>
-        </p:spPr>
-        <p:txBody>
-          <a:bodyPr wrap="square" anchor="t" lIns="0" rIns="0" tIns="0" bIns="0">
-            <a:spAutoFit/>
-          </a:bodyPr>
-          <a:lstStyle/>
-          <a:p>
-            <a:pPr algn="l">
-              <a:lnSpc>
-                <a:spcPct val="102000"/>
-              </a:lnSpc>
-            </a:pPr>
-            <a:r>
-              <a:rPr sz="950" b="1">
-                <a:solidFill>
-                  <a:srgbClr val="20242C"/>
-                </a:solidFill>
-                <a:latin typeface="Microsoft YaHei"/>
-              </a:rPr>
-              <a:t>S16 授权保留。</a:t>
-            </a:r>
-            <a:r>
-              <a:rPr sz="950" b="0">
-                <a:solidFill>
-                  <a:srgbClr val="20242C"/>
-                </a:solidFill>
-                <a:latin typeface="Microsoft YaHei"/>
-              </a:rPr>
-              <a:t>写侧 Jain 0.92818 → 0.98466、带宽只让 0.39%、非均匀流量拿到 R* 的 99.74%。</a:t>
+                  <a:srgbClr val="20242C"/>
+                </a:solidFill>
+                <a:latin typeface="Microsoft YaHei"/>
+              </a:rPr>
+              <a:t>验证重点</a:t>
+            </a:r>
+            <a:r>
+              <a:rPr sz="1150" b="0">
+                <a:solidFill>
+                  <a:srgbClr val="20242C"/>
+                </a:solidFill>
+                <a:latin typeface="Microsoft YaHei"/>
+              </a:rPr>
+              <a:t>：6 bit 进度总线复用、30 拍反馈稳定性、让路范围和现有注入队列深度下的收益。</a:t>
             </a:r>
           </a:p>
           <a:p>
@@ -25184,22 +25268,22 @@
               </a:spcBef>
             </a:pPr>
             <a:r>
-              <a:rPr sz="950" b="1">
-                <a:solidFill>
-                  <a:srgbClr val="20242C"/>
-                </a:solidFill>
-                <a:latin typeface="Microsoft YaHei"/>
-              </a:rPr>
-              <a:t>前提</a:t>
-            </a:r>
-            <a:r>
-              <a:rPr sz="950" b="0">
-                <a:solidFill>
-                  <a:srgbClr val="20242C"/>
-                </a:solidFill>
-                <a:latin typeface="Microsoft YaHei"/>
-              </a:rPr>
-              <a:t>：completer 的授权调度可改。线格式与协议状态机不动，但要改 HA 何时给谁发 DBIDResp，须 IP 可改并过一次合规复核。</a:t>
+              <a:rPr sz="1150" b="1">
+                <a:solidFill>
+                  <a:srgbClr val="20242C"/>
+                </a:solidFill>
+                <a:latin typeface="Microsoft YaHei"/>
+              </a:rPr>
+              <a:t>定位</a:t>
+            </a:r>
+            <a:r>
+              <a:rPr sz="1150" b="0">
+                <a:solidFill>
+                  <a:srgbClr val="20242C"/>
+                </a:solidFill>
+                <a:latin typeface="Microsoft YaHei"/>
+              </a:rPr>
+              <a:t>：性能次于 S16，但控制面完全留在环层。</a:t>
             </a:r>
           </a:p>
         </p:txBody>
@@ -25212,8 +25296,8 @@
         </p:nvSpPr>
         <p:spPr>
           <a:xfrm>
-            <a:off x="6205575" y="2194560"/>
-            <a:ext cx="2599867" cy="3017520"/>
+            <a:off x="8085124" y="2194560"/>
+            <a:ext cx="3539642" cy="3017520"/>
           </a:xfrm>
           <a:prstGeom prst="rect">
             <a:avLst/>
@@ -25258,7 +25342,7 @@
         </p:nvSpPr>
         <p:spPr>
           <a:xfrm>
-            <a:off x="6425031" y="2414016"/>
+            <a:off x="8304580" y="2414016"/>
             <a:ext cx="384048" cy="384048"/>
           </a:xfrm>
           <a:prstGeom prst="ellipse">
@@ -25302,7 +25386,7 @@
         </p:nvSpPr>
         <p:spPr>
           <a:xfrm>
-            <a:off x="6425031" y="2496312"/>
+            <a:off x="8304580" y="2496312"/>
             <a:ext cx="384048" cy="237744"/>
           </a:xfrm>
           <a:prstGeom prst="rect">
@@ -25341,8 +25425,8 @@
         </p:nvSpPr>
         <p:spPr>
           <a:xfrm>
-            <a:off x="6425031" y="3195934"/>
-            <a:ext cx="2160955" cy="592836"/>
+            <a:off x="8304580" y="3069671"/>
+            <a:ext cx="3100730" cy="314705"/>
           </a:xfrm>
           <a:prstGeom prst="rect">
             <a:avLst/>
@@ -25367,7 +25451,7 @@
                 </a:solidFill>
                 <a:latin typeface="Microsoft YaHei"/>
               </a:rPr>
-              <a:t>只改环上仲裁 · 13,920 FF‑eq</a:t>
+              <a:t>边界 · 明确不进入建议</a:t>
             </a:r>
           </a:p>
         </p:txBody>
@@ -25380,8 +25464,8 @@
         </p:nvSpPr>
         <p:spPr>
           <a:xfrm>
-            <a:off x="6425031" y="3871066"/>
-            <a:ext cx="2160955" cy="906566"/>
+            <a:off x="8304580" y="3466673"/>
+            <a:ext cx="3100730" cy="1437223"/>
           </a:xfrm>
           <a:prstGeom prst="rect">
             <a:avLst/>
@@ -25400,22 +25484,78 @@
               </a:lnSpc>
             </a:pPr>
             <a:r>
-              <a:rPr sz="1150" b="1">
-                <a:solidFill>
-                  <a:srgbClr val="20242C"/>
-                </a:solidFill>
-                <a:latin typeface="Microsoft YaHei"/>
-              </a:rPr>
-              <a:t>S22</a:t>
-            </a:r>
-            <a:r>
-              <a:rPr sz="1150" b="0">
-                <a:solidFill>
-                  <a:srgbClr val="20242C"/>
-                </a:solidFill>
-                <a:latin typeface="Microsoft YaHei"/>
-              </a:rPr>
-              <a:t>：复用 6 bit 进度总线，能直接比较谁领先、谁落后；适合允许跨节点进度信息、但事务层不可改的场景。</a:t>
+              <a:rPr sz="1100" b="1">
+                <a:solidFill>
+                  <a:srgbClr val="20242C"/>
+                </a:solidFill>
+                <a:latin typeface="Microsoft YaHei"/>
+              </a:rPr>
+              <a:t>S19 / S20</a:t>
+            </a:r>
+            <a:r>
+              <a:rPr sz="1100" b="0">
+                <a:solidFill>
+                  <a:srgbClr val="20242C"/>
+                </a:solidFill>
+                <a:latin typeface="Microsoft YaHei"/>
+              </a:rPr>
+              <a:t>：仅保留为 requester-side 研究对照；实测公平性几乎不变，不作为第三层落地路径。</a:t>
+            </a:r>
+          </a:p>
+          <a:p>
+            <a:pPr algn="l">
+              <a:lnSpc>
+                <a:spcPct val="102000"/>
+              </a:lnSpc>
+              <a:spcBef>
+                <a:spcPts val="600"/>
+              </a:spcBef>
+            </a:pPr>
+            <a:r>
+              <a:rPr sz="1100" b="1">
+                <a:solidFill>
+                  <a:srgbClr val="20242C"/>
+                </a:solidFill>
+                <a:latin typeface="Microsoft YaHei"/>
+              </a:rPr>
+              <a:t>读侧</a:t>
+            </a:r>
+            <a:r>
+              <a:rPr sz="1100" b="0">
+                <a:solidFill>
+                  <a:srgbClr val="20242C"/>
+                </a:solidFill>
+                <a:latin typeface="Microsoft YaHei"/>
+              </a:rPr>
+              <a:t>：S0 已达到 Jain 0.99067、max/min 1.0035，维持现状。</a:t>
+            </a:r>
+          </a:p>
+          <a:p>
+            <a:pPr algn="l">
+              <a:lnSpc>
+                <a:spcPct val="102000"/>
+              </a:lnSpc>
+              <a:spcBef>
+                <a:spcPts val="600"/>
+              </a:spcBef>
+            </a:pPr>
+            <a:r>
+              <a:rPr sz="1100" b="1">
+                <a:solidFill>
+                  <a:srgbClr val="20242C"/>
+                </a:solidFill>
+                <a:latin typeface="Microsoft YaHei"/>
+              </a:rPr>
+              <a:t>outstanding</a:t>
+            </a:r>
+            <a:r>
+              <a:rPr sz="1100" b="0">
+                <a:solidFill>
+                  <a:srgbClr val="20242C"/>
+                </a:solidFill>
+                <a:latin typeface="Microsoft YaHei"/>
+              </a:rPr>
+              <a:t>：由最坏 RTT 覆盖要求固定，不作为拥塞控制旋钮。</a:t>
             </a:r>
           </a:p>
         </p:txBody>
@@ -25428,56 +25568,10 @@
         </p:nvSpPr>
         <p:spPr>
           <a:xfrm>
-            <a:off x="9024899" y="2194560"/>
-            <a:ext cx="2599867" cy="3017520"/>
-          </a:xfrm>
-          <a:prstGeom prst="rect">
-            <a:avLst/>
-          </a:prstGeom>
-          <a:solidFill>
-            <a:srgbClr val="FFFFFF"/>
-          </a:solidFill>
-          <a:ln w="12700">
-            <a:solidFill>
-              <a:srgbClr val="DCE3EA"/>
-            </a:solidFill>
-          </a:ln>
-          <a:effectLst/>
-        </p:spPr>
-        <p:style>
-          <a:lnRef idx="1">
-            <a:schemeClr val="accent1"/>
-          </a:lnRef>
-          <a:fillRef idx="3">
-            <a:schemeClr val="accent1"/>
-          </a:fillRef>
-          <a:effectRef idx="2">
-            <a:schemeClr val="accent1"/>
-          </a:effectRef>
-          <a:fontRef idx="minor">
-            <a:schemeClr val="lt1"/>
-          </a:fontRef>
-        </p:style>
-        <p:txBody>
-          <a:bodyPr rtlCol="0" anchor="ctr" wrap="square"/>
-          <a:lstStyle/>
-          <a:p>
-            <a:pPr algn="ctr"/>
-          </a:p>
-        </p:txBody>
-      </p:sp>
-      <p:sp>
-        <p:nvSpPr>
-          <p:cNvPr id="26" name="Oval 25"/>
-          <p:cNvSpPr/>
-          <p:nvPr/>
-        </p:nvSpPr>
-        <p:spPr>
-          <a:xfrm>
-            <a:off x="9244355" y="2414016"/>
-            <a:ext cx="384048" cy="384048"/>
-          </a:xfrm>
-          <a:prstGeom prst="ellipse">
+            <a:off x="566928" y="5486400"/>
+            <a:ext cx="11057839" cy="841248"/>
+          </a:xfrm>
+          <a:prstGeom prst="rect">
             <a:avLst/>
           </a:prstGeom>
           <a:solidFill>
@@ -25512,196 +25606,7 @@
       </p:sp>
       <p:sp>
         <p:nvSpPr>
-          <p:cNvPr id="27" name="TextBox 26"/>
-          <p:cNvSpPr txBox="1"/>
-          <p:nvPr/>
-        </p:nvSpPr>
-        <p:spPr>
-          <a:xfrm>
-            <a:off x="9244355" y="2496312"/>
-            <a:ext cx="384048" cy="237744"/>
-          </a:xfrm>
-          <a:prstGeom prst="rect">
-            <a:avLst/>
-          </a:prstGeom>
-          <a:noFill/>
-        </p:spPr>
-        <p:txBody>
-          <a:bodyPr wrap="square" anchor="t" lIns="0" rIns="0" tIns="0" bIns="0">
-            <a:spAutoFit/>
-          </a:bodyPr>
-          <a:lstStyle/>
-          <a:p>
-            <a:pPr algn="ctr">
-              <a:lnSpc>
-                <a:spcPct val="100000"/>
-              </a:lnSpc>
-            </a:pPr>
-            <a:r>
-              <a:rPr sz="1150" b="1">
-                <a:solidFill>
-                  <a:srgbClr val="FFFFFF"/>
-                </a:solidFill>
-                <a:latin typeface="Arial"/>
-              </a:rPr>
-              <a:t>04</a:t>
-            </a:r>
-          </a:p>
-        </p:txBody>
-      </p:sp>
-      <p:sp>
-        <p:nvSpPr>
-          <p:cNvPr id="28" name="TextBox 27"/>
-          <p:cNvSpPr txBox="1"/>
-          <p:nvPr/>
-        </p:nvSpPr>
-        <p:spPr>
-          <a:xfrm>
-            <a:off x="9244355" y="2963978"/>
-            <a:ext cx="2160955" cy="592836"/>
-          </a:xfrm>
-          <a:prstGeom prst="rect">
-            <a:avLst/>
-          </a:prstGeom>
-          <a:noFill/>
-        </p:spPr>
-        <p:txBody>
-          <a:bodyPr wrap="square" anchor="t" lIns="0" rIns="0" tIns="0" bIns="0">
-            <a:spAutoFit/>
-          </a:bodyPr>
-          <a:lstStyle/>
-          <a:p>
-            <a:pPr algn="l">
-              <a:lnSpc>
-                <a:spcPct val="100000"/>
-              </a:lnSpc>
-            </a:pPr>
-            <a:r>
-              <a:rPr sz="1500" b="1">
-                <a:solidFill>
-                  <a:srgbClr val="20242C"/>
-                </a:solidFill>
-                <a:latin typeface="Microsoft YaHei"/>
-              </a:rPr>
-              <a:t>requester 窗口可改 · 5,840 FF‑eq</a:t>
-            </a:r>
-          </a:p>
-        </p:txBody>
-      </p:sp>
-      <p:sp>
-        <p:nvSpPr>
-          <p:cNvPr id="29" name="TextBox 28"/>
-          <p:cNvSpPr txBox="1"/>
-          <p:nvPr/>
-        </p:nvSpPr>
-        <p:spPr>
-          <a:xfrm>
-            <a:off x="9244355" y="3639110"/>
-            <a:ext cx="2160955" cy="1370479"/>
-          </a:xfrm>
-          <a:prstGeom prst="rect">
-            <a:avLst/>
-          </a:prstGeom>
-          <a:noFill/>
-        </p:spPr>
-        <p:txBody>
-          <a:bodyPr wrap="square" anchor="t" lIns="0" rIns="0" tIns="0" bIns="0">
-            <a:spAutoFit/>
-          </a:bodyPr>
-          <a:lstStyle/>
-          <a:p>
-            <a:pPr algn="l">
-              <a:lnSpc>
-                <a:spcPct val="102000"/>
-              </a:lnSpc>
-            </a:pPr>
-            <a:r>
-              <a:rPr sz="950" b="1">
-                <a:solidFill>
-                  <a:srgbClr val="20242C"/>
-                </a:solidFill>
-                <a:latin typeface="Microsoft YaHei"/>
-              </a:rPr>
-              <a:t>S19 / S20</a:t>
-            </a:r>
-            <a:r>
-              <a:rPr sz="950" b="0">
-                <a:solidFill>
-                  <a:srgbClr val="20242C"/>
-                </a:solidFill>
-                <a:latin typeface="Microsoft YaHei"/>
-              </a:rPr>
-              <a:t>：都用每核动态 outstanding 窗口。已有 RTT 计时器时选 S19；已有 tracker 水位和 1 bit 标记位时选 S20。</a:t>
-            </a:r>
-          </a:p>
-          <a:p>
-            <a:pPr algn="l">
-              <a:lnSpc>
-                <a:spcPct val="102000"/>
-              </a:lnSpc>
-              <a:spcBef>
-                <a:spcPts val="600"/>
-              </a:spcBef>
-            </a:pPr>
-            <a:r>
-              <a:rPr sz="950" b="0">
-                <a:solidFill>
-                  <a:srgbClr val="20242C"/>
-                </a:solidFill>
-                <a:latin typeface="Microsoft YaHei"/>
-              </a:rPr>
-              <a:t>两者不需要流量 pattern 先验，可作为 source-side 集成路径。读侧维持 S0，不另加控制。</a:t>
-            </a:r>
-          </a:p>
-        </p:txBody>
-      </p:sp>
-      <p:sp>
-        <p:nvSpPr>
-          <p:cNvPr id="30" name="Rectangle 29"/>
-          <p:cNvSpPr/>
-          <p:nvPr/>
-        </p:nvSpPr>
-        <p:spPr>
-          <a:xfrm>
-            <a:off x="566928" y="5486400"/>
-            <a:ext cx="11057839" cy="841248"/>
-          </a:xfrm>
-          <a:prstGeom prst="rect">
-            <a:avLst/>
-          </a:prstGeom>
-          <a:solidFill>
-            <a:srgbClr val="D20A2E"/>
-          </a:solidFill>
-          <a:ln>
-            <a:noFill/>
-          </a:ln>
-          <a:effectLst/>
-        </p:spPr>
-        <p:style>
-          <a:lnRef idx="1">
-            <a:schemeClr val="accent1"/>
-          </a:lnRef>
-          <a:fillRef idx="3">
-            <a:schemeClr val="accent1"/>
-          </a:fillRef>
-          <a:effectRef idx="2">
-            <a:schemeClr val="accent1"/>
-          </a:effectRef>
-          <a:fontRef idx="minor">
-            <a:schemeClr val="lt1"/>
-          </a:fontRef>
-        </p:style>
-        <p:txBody>
-          <a:bodyPr rtlCol="0" anchor="ctr" wrap="square"/>
-          <a:lstStyle/>
-          <a:p>
-            <a:pPr algn="ctr"/>
-          </a:p>
-        </p:txBody>
-      </p:sp>
-      <p:sp>
-        <p:nvSpPr>
-          <p:cNvPr id="31" name="TextBox 30"/>
+          <p:cNvPr id="26" name="TextBox 25"/>
           <p:cNvSpPr txBox="1"/>
           <p:nvPr/>
         </p:nvSpPr>
@@ -25733,14 +25638,14 @@
                 </a:solidFill>
                 <a:latin typeface="Microsoft YaHei"/>
               </a:rPr>
-              <a:t>建议顺序：第 1 步直接做；随后先问 completer 能不能改。能改优先验证 S16；不能改，再按现有硬件基础在 S22、S19 / S20 中选。</a:t>
-            </a:r>
-          </a:p>
-        </p:txBody>
-      </p:sp>
-      <p:sp>
-        <p:nvSpPr>
-          <p:cNvPr id="32" name="TextBox 31"/>
+              <a:t>请架构组只决策一件事：是否允许 HA 改变授权的时机与对象。允许则进入 S16 微架构验证；不允许则转入 S22 环仲裁原型。</a:t>
+            </a:r>
+          </a:p>
+        </p:txBody>
+      </p:sp>
+      <p:sp>
+        <p:nvSpPr>
+          <p:cNvPr id="27" name="TextBox 26"/>
           <p:cNvSpPr txBox="1"/>
           <p:nvPr/>
         </p:nvSpPr>
@@ -26160,7 +26065,7 @@
                 </a:solidFill>
                 <a:latin typeface="Microsoft YaHei"/>
               </a:rPr>
-              <a:t>能改优先 S16；不能改，再选择跨节点 S22，或 requester 动态窗口 S19 / S20。</a:t>
+              <a:t>允许修改：进入 S16 微架构验证；不允许修改：进入 S22 环仲裁原型。</a:t>
             </a:r>
           </a:p>
         </p:txBody>
@@ -30920,7 +30825,7 @@
         </p:nvSpPr>
         <p:spPr>
           <a:xfrm>
-            <a:off x="4533290" y="4611466"/>
+            <a:off x="4533290" y="4507445"/>
             <a:ext cx="3125114" cy="277622"/>
           </a:xfrm>
           <a:prstGeom prst="rect">
@@ -30959,8 +30864,8 @@
         </p:nvSpPr>
         <p:spPr>
           <a:xfrm>
-            <a:off x="4533290" y="4971384"/>
-            <a:ext cx="3125114" cy="868740"/>
+            <a:off x="4533290" y="4867363"/>
+            <a:ext cx="3125114" cy="1076782"/>
           </a:xfrm>
           <a:prstGeom prst="rect">
             <a:avLst/>
@@ -31003,7 +30908,7 @@
                 </a:solidFill>
                 <a:latin typeface="Microsoft YaHei"/>
               </a:rPr>
-              <a:t>，三项逐拍相加相等。在飞上限收到 32 之后，绕环重发已经从上千拍降到 5 拍。</a:t>
+              <a:t>，三项逐拍相加相等。core_outstanding 固定为 32、覆盖最坏 RTT；在这个前提下，绕环重发仅 5 拍，剩余缺口来自已分类的空转。</a:t>
             </a:r>
           </a:p>
         </p:txBody>
@@ -31182,7 +31087,7 @@
                 </a:solidFill>
                 <a:latin typeface="Microsoft YaHei"/>
               </a:rPr>
-              <a:t>能回收的不到 1 个点，且要拿公平性换：I-tag 调强可到 97.59% R*，但 Jain 掉 0.029；加深下环队列、加大在飞上限都是净亏。</a:t>
+              <a:t>能回收的不到 1 个点，且要拿公平性换：I-tag 调强可到 97.59% R*，但 Jain 掉 0.029；加深下环队列也不能改善这一结论。</a:t>
             </a:r>
           </a:p>
         </p:txBody>

</xml_diff>

<commit_message>
Align the CC taxonomy slides with the two-axis grid and plot every official-K scheme on the fairness-bandwidth curve.
Co-authored-by: Cursor <cursoragent@cursor.com>
</commit_message>
<xml_diff>
--- a/ppt/ring2-write-fairness.pptx
+++ b/ppt/ring2-write-fairness.pptx
@@ -10350,7 +10350,7 @@
                 </a:solidFill>
                 <a:latin typeface="Microsoft YaHei"/>
               </a:rPr>
-              <a:t>按「在哪里动手」和「听什么信号」把文献里的拥塞控制分成八类，给出各类优缺点，定位 S1，并补齐本研究原本没有代表方案的四类。</a:t>
+              <a:t>按第 19 页的两个正交维度分类：先按拥塞信号（行），再按控制点（列），给出各类优缺点，定位 S1，并补齐本研究原本没有代表方案的四个格子。</a:t>
             </a:r>
           </a:p>
         </p:txBody>
@@ -10656,7 +10656,7 @@
                 </a:solidFill>
                 <a:latin typeface="Microsoft YaHei"/>
               </a:rPr>
-              <a:t>分类 · 控制点 ①–④</a:t>
+              <a:t>分类 · 拥塞信号（第 19 页的行）</a:t>
             </a:r>
           </a:p>
         </p:txBody>
@@ -10822,7 +10822,7 @@
                 </a:solidFill>
                 <a:latin typeface="Arial"/>
               </a:rPr>
-              <a:t>T A X O N O M Y   B Y   C O N T R O L   P O I N T   ·   1   /   2</a:t>
+              <a:t>T A X O N O M Y   B Y   S I G N A L     =     P A G E   1 9   R O W S</a:t>
             </a:r>
           </a:p>
         </p:txBody>
@@ -10861,7 +10861,7 @@
                 </a:solidFill>
                 <a:latin typeface="Microsoft YaHei"/>
               </a:rPr>
-              <a:t>动手的地方决定天花板：路由、背压、两种源端限速</a:t>
+              <a:t>听什么决定盲区（= 第 19 页的行）</a:t>
             </a:r>
           </a:p>
         </p:txBody>
@@ -10874,8 +10874,8 @@
         </p:nvSpPr>
         <p:spPr>
           <a:xfrm>
-            <a:off x="566928" y="2971083"/>
-            <a:ext cx="2599867" cy="2616616"/>
+            <a:off x="566928" y="2252814"/>
+            <a:ext cx="2599867" cy="1916849"/>
           </a:xfrm>
           <a:prstGeom prst="rect">
             <a:avLst/>
@@ -10920,8 +10920,8 @@
         </p:nvSpPr>
         <p:spPr>
           <a:xfrm>
-            <a:off x="768096" y="3285728"/>
-            <a:ext cx="2197531" cy="314705"/>
+            <a:off x="768096" y="2453982"/>
+            <a:ext cx="2197531" cy="286893"/>
           </a:xfrm>
           <a:prstGeom prst="rect">
             <a:avLst/>
@@ -10940,13 +10940,13 @@
               </a:lnSpc>
             </a:pPr>
             <a:r>
-              <a:rPr sz="1500" b="1">
-                <a:solidFill>
-                  <a:srgbClr val="20242C"/>
-                </a:solidFill>
-                <a:latin typeface="Microsoft YaHei"/>
-              </a:rPr>
-              <a:t>① 自适应路由</a:t>
+              <a:rPr sz="1350" b="1">
+                <a:solidFill>
+                  <a:srgbClr val="20242C"/>
+                </a:solidFill>
+                <a:latin typeface="Microsoft YaHei"/>
+              </a:rPr>
+              <a:t>无信号 / 1 bit 需求</a:t>
             </a:r>
           </a:p>
         </p:txBody>
@@ -10959,8 +10959,8 @@
         </p:nvSpPr>
         <p:spPr>
           <a:xfrm>
-            <a:off x="768096" y="3682730"/>
-            <a:ext cx="2197531" cy="1626900"/>
+            <a:off x="768096" y="2823171"/>
+            <a:ext cx="2197531" cy="1181900"/>
           </a:xfrm>
           <a:prstGeom prst="rect">
             <a:avLst/>
@@ -10979,7 +10979,7 @@
               </a:lnSpc>
             </a:pPr>
             <a:r>
-              <a:rPr sz="1200" b="1">
+              <a:rPr sz="1050" b="1">
                 <a:solidFill>
                   <a:srgbClr val="20242C"/>
                 </a:solidFill>
@@ -10988,13 +10988,13 @@
               <a:t>代表</a:t>
             </a:r>
             <a:r>
-              <a:rPr sz="1200" b="0">
-                <a:solidFill>
-                  <a:srgbClr val="20242C"/>
-                </a:solidFill>
-                <a:latin typeface="Microsoft YaHei"/>
-              </a:rPr>
-              <a:t>：UGAL / Valiant / CQR。</a:t>
+              <a:rPr sz="1050" b="0">
+                <a:solidFill>
+                  <a:srgbClr val="20242C"/>
+                </a:solidFill>
+                <a:latin typeface="Microsoft YaHei"/>
+              </a:rPr>
+              <a:t>：S29。</a:t>
             </a:r>
           </a:p>
           <a:p>
@@ -11007,22 +11007,22 @@
               </a:spcBef>
             </a:pPr>
             <a:r>
-              <a:rPr sz="1200" b="1">
-                <a:solidFill>
-                  <a:srgbClr val="20242C"/>
-                </a:solidFill>
-                <a:latin typeface="Microsoft YaHei"/>
-              </a:rPr>
-              <a:t>动手处</a:t>
-            </a:r>
-            <a:r>
-              <a:rPr sz="1200" b="0">
-                <a:solidFill>
-                  <a:srgbClr val="20242C"/>
-                </a:solidFill>
-                <a:latin typeface="Microsoft YaHei"/>
-              </a:rPr>
-              <a:t>：路径选择。</a:t>
+              <a:rPr sz="1050" b="1">
+                <a:solidFill>
+                  <a:srgbClr val="20242C"/>
+                </a:solidFill>
+                <a:latin typeface="Microsoft YaHei"/>
+              </a:rPr>
+              <a:t>听什么</a:t>
+            </a:r>
+            <a:r>
+              <a:rPr sz="1050" b="0">
+                <a:solidFill>
+                  <a:srgbClr val="20242C"/>
+                </a:solidFill>
+                <a:latin typeface="Microsoft YaHei"/>
+              </a:rPr>
+              <a:t>：固定日历 + 每核 1 bit「有活」。</a:t>
             </a:r>
           </a:p>
           <a:p>
@@ -11035,7 +11035,7 @@
               </a:spcBef>
             </a:pPr>
             <a:r>
-              <a:rPr sz="1200" b="1">
+              <a:rPr sz="1050" b="1">
                 <a:solidFill>
                   <a:srgbClr val="20242C"/>
                 </a:solidFill>
@@ -11044,26 +11044,16 @@
               <a:t>优</a:t>
             </a:r>
             <a:r>
-              <a:rPr sz="1200" b="0">
-                <a:solidFill>
-                  <a:srgbClr val="20242C"/>
-                </a:solidFill>
-                <a:latin typeface="Microsoft YaHei"/>
-              </a:rPr>
-              <a:t>：不减少任何人的注入量，只换路径，理论上零吞吐代价。</a:t>
-            </a:r>
-          </a:p>
-          <a:p>
-            <a:pPr algn="l">
-              <a:lnSpc>
-                <a:spcPct val="102000"/>
-              </a:lnSpc>
-              <a:spcBef>
-                <a:spcPts val="600"/>
-              </a:spcBef>
-            </a:pPr>
-            <a:r>
-              <a:rPr sz="1200" b="1">
+              <a:rPr sz="1050" b="0">
+                <a:solidFill>
+                  <a:srgbClr val="20242C"/>
+                </a:solidFill>
+                <a:latin typeface="Microsoft YaHei"/>
+              </a:rPr>
+              <a:t>：无测量、无收敛。</a:t>
+            </a:r>
+            <a:r>
+              <a:rPr sz="1050" b="1">
                 <a:solidFill>
                   <a:srgbClr val="20242C"/>
                 </a:solidFill>
@@ -11072,13 +11062,13 @@
               <a:t>缺</a:t>
             </a:r>
             <a:r>
-              <a:rPr sz="1200" b="0">
-                <a:solidFill>
-                  <a:srgbClr val="20242C"/>
-                </a:solidFill>
-                <a:latin typeface="Microsoft YaHei"/>
-              </a:rPr>
-              <a:t>：要有非最短路可走，而绕远本身要多占链路容量。</a:t>
+              <a:rPr sz="1050" b="0">
+                <a:solidFill>
+                  <a:srgbClr val="20242C"/>
+                </a:solidFill>
+                <a:latin typeface="Microsoft YaHei"/>
+              </a:rPr>
+              <a:t>：不知道谁落后。</a:t>
             </a:r>
           </a:p>
         </p:txBody>
@@ -11091,8 +11081,8 @@
         </p:nvSpPr>
         <p:spPr>
           <a:xfrm>
-            <a:off x="3386251" y="2971083"/>
-            <a:ext cx="2599867" cy="2616616"/>
+            <a:off x="3386251" y="2252814"/>
+            <a:ext cx="2599867" cy="1916849"/>
           </a:xfrm>
           <a:prstGeom prst="rect">
             <a:avLst/>
@@ -11137,8 +11127,8 @@
         </p:nvSpPr>
         <p:spPr>
           <a:xfrm>
-            <a:off x="3587419" y="3172251"/>
-            <a:ext cx="2197531" cy="314705"/>
+            <a:off x="3587419" y="2453982"/>
+            <a:ext cx="2197531" cy="286893"/>
           </a:xfrm>
           <a:prstGeom prst="rect">
             <a:avLst/>
@@ -11157,13 +11147,13 @@
               </a:lnSpc>
             </a:pPr>
             <a:r>
-              <a:rPr sz="1500" b="1">
-                <a:solidFill>
-                  <a:srgbClr val="20242C"/>
-                </a:solidFill>
-                <a:latin typeface="Microsoft YaHei"/>
-              </a:rPr>
-              <a:t>② 逐跳背压</a:t>
+              <a:rPr sz="1350" b="1">
+                <a:solidFill>
+                  <a:srgbClr val="20242C"/>
+                </a:solidFill>
+                <a:latin typeface="Microsoft YaHei"/>
+              </a:rPr>
+              <a:t>本地观测</a:t>
             </a:r>
           </a:p>
         </p:txBody>
@@ -11176,8 +11166,8 @@
         </p:nvSpPr>
         <p:spPr>
           <a:xfrm>
-            <a:off x="3587419" y="3569253"/>
-            <a:ext cx="2197531" cy="1853854"/>
+            <a:off x="3587419" y="2823171"/>
+            <a:ext cx="2197531" cy="1181900"/>
           </a:xfrm>
           <a:prstGeom prst="rect">
             <a:avLst/>
@@ -11196,7 +11186,7 @@
               </a:lnSpc>
             </a:pPr>
             <a:r>
-              <a:rPr sz="1200" b="1">
+              <a:rPr sz="1050" b="1">
                 <a:solidFill>
                   <a:srgbClr val="20242C"/>
                 </a:solidFill>
@@ -11205,13 +11195,13 @@
               <a:t>代表</a:t>
             </a:r>
             <a:r>
-              <a:rPr sz="1200" b="0">
-                <a:solidFill>
-                  <a:srgbClr val="20242C"/>
-                </a:solidFill>
-                <a:latin typeface="Microsoft YaHei"/>
-              </a:rPr>
-              <a:t>：Credit FC / PFC / wormhole 背压。</a:t>
+              <a:rPr sz="1050" b="0">
+                <a:solidFill>
+                  <a:srgbClr val="20242C"/>
+                </a:solidFill>
+                <a:latin typeface="Microsoft YaHei"/>
+              </a:rPr>
+              <a:t>：S16 / S21 / S26 / I-tag。</a:t>
             </a:r>
           </a:p>
           <a:p>
@@ -11224,22 +11214,22 @@
               </a:spcBef>
             </a:pPr>
             <a:r>
-              <a:rPr sz="1200" b="1">
-                <a:solidFill>
-                  <a:srgbClr val="20242C"/>
-                </a:solidFill>
-                <a:latin typeface="Microsoft YaHei"/>
-              </a:rPr>
-              <a:t>动手处</a:t>
-            </a:r>
-            <a:r>
-              <a:rPr sz="1200" b="0">
-                <a:solidFill>
-                  <a:srgbClr val="20242C"/>
-                </a:solidFill>
-                <a:latin typeface="Microsoft YaHei"/>
-              </a:rPr>
-              <a:t>：上游链路。</a:t>
+              <a:rPr sz="1050" b="1">
+                <a:solidFill>
+                  <a:srgbClr val="20242C"/>
+                </a:solidFill>
+                <a:latin typeface="Microsoft YaHei"/>
+              </a:rPr>
+              <a:t>听什么</a:t>
+            </a:r>
+            <a:r>
+              <a:rPr sz="1050" b="0">
+                <a:solidFill>
+                  <a:srgbClr val="20242C"/>
+                </a:solidFill>
+                <a:latin typeface="Microsoft YaHei"/>
+              </a:rPr>
+              <a:t>：本节点的占用、失败或授权数。</a:t>
             </a:r>
           </a:p>
           <a:p>
@@ -11252,7 +11242,7 @@
               </a:spcBef>
             </a:pPr>
             <a:r>
-              <a:rPr sz="1200" b="1">
+              <a:rPr sz="1050" b="1">
                 <a:solidFill>
                   <a:srgbClr val="20242C"/>
                 </a:solidFill>
@@ -11261,13 +11251,164 @@
               <a:t>优</a:t>
             </a:r>
             <a:r>
-              <a:rPr sz="1200" b="0">
-                <a:solidFill>
-                  <a:srgbClr val="20242C"/>
-                </a:solidFill>
-                <a:latin typeface="Microsoft YaHei"/>
-              </a:rPr>
-              <a:t>：结构上不丢包，不需要测量任何全局量，实现最简单。</a:t>
+              <a:rPr sz="1050" b="0">
+                <a:solidFill>
+                  <a:srgbClr val="20242C"/>
+                </a:solidFill>
+                <a:latin typeface="Microsoft YaHei"/>
+              </a:rPr>
+              <a:t>：零新报文。</a:t>
+            </a:r>
+            <a:r>
+              <a:rPr sz="1050" b="1">
+                <a:solidFill>
+                  <a:srgbClr val="20242C"/>
+                </a:solidFill>
+                <a:latin typeface="Microsoft YaHei"/>
+              </a:rPr>
+              <a:t>缺</a:t>
+            </a:r>
+            <a:r>
+              <a:rPr sz="1050" b="0">
+                <a:solidFill>
+                  <a:srgbClr val="20242C"/>
+                </a:solidFill>
+                <a:latin typeface="Microsoft YaHei"/>
+              </a:rPr>
+              <a:t>：源端格子会把别人造成的失败算到自己头上。</a:t>
+            </a:r>
+          </a:p>
+        </p:txBody>
+      </p:sp>
+      <p:sp>
+        <p:nvSpPr>
+          <p:cNvPr id="16" name="Rectangle 15"/>
+          <p:cNvSpPr/>
+          <p:nvPr/>
+        </p:nvSpPr>
+        <p:spPr>
+          <a:xfrm>
+            <a:off x="6205575" y="2252814"/>
+            <a:ext cx="2599867" cy="1916849"/>
+          </a:xfrm>
+          <a:prstGeom prst="rect">
+            <a:avLst/>
+          </a:prstGeom>
+          <a:solidFill>
+            <a:srgbClr val="FFFFFF"/>
+          </a:solidFill>
+          <a:ln w="12700">
+            <a:solidFill>
+              <a:srgbClr val="DCE3EA"/>
+            </a:solidFill>
+          </a:ln>
+          <a:effectLst/>
+        </p:spPr>
+        <p:style>
+          <a:lnRef idx="1">
+            <a:schemeClr val="accent1"/>
+          </a:lnRef>
+          <a:fillRef idx="3">
+            <a:schemeClr val="accent1"/>
+          </a:fillRef>
+          <a:effectRef idx="2">
+            <a:schemeClr val="accent1"/>
+          </a:effectRef>
+          <a:fontRef idx="minor">
+            <a:schemeClr val="lt1"/>
+          </a:fontRef>
+        </p:style>
+        <p:txBody>
+          <a:bodyPr rtlCol="0" anchor="ctr" wrap="square"/>
+          <a:lstStyle/>
+          <a:p>
+            <a:pPr algn="ctr"/>
+          </a:p>
+        </p:txBody>
+      </p:sp>
+      <p:sp>
+        <p:nvSpPr>
+          <p:cNvPr id="17" name="TextBox 16"/>
+          <p:cNvSpPr txBox="1"/>
+          <p:nvPr/>
+        </p:nvSpPr>
+        <p:spPr>
+          <a:xfrm>
+            <a:off x="6406743" y="2553275"/>
+            <a:ext cx="2197531" cy="286893"/>
+          </a:xfrm>
+          <a:prstGeom prst="rect">
+            <a:avLst/>
+          </a:prstGeom>
+          <a:noFill/>
+        </p:spPr>
+        <p:txBody>
+          <a:bodyPr wrap="square" anchor="t" lIns="0" rIns="0" tIns="0" bIns="0">
+            <a:spAutoFit/>
+          </a:bodyPr>
+          <a:lstStyle/>
+          <a:p>
+            <a:pPr algn="l">
+              <a:lnSpc>
+                <a:spcPct val="100000"/>
+              </a:lnSpc>
+            </a:pPr>
+            <a:r>
+              <a:rPr sz="1350" b="1">
+                <a:solidFill>
+                  <a:srgbClr val="20242C"/>
+                </a:solidFill>
+                <a:latin typeface="Microsoft YaHei"/>
+              </a:rPr>
+              <a:t>链路占用</a:t>
+            </a:r>
+          </a:p>
+        </p:txBody>
+      </p:sp>
+      <p:sp>
+        <p:nvSpPr>
+          <p:cNvPr id="18" name="TextBox 17"/>
+          <p:cNvSpPr txBox="1"/>
+          <p:nvPr/>
+        </p:nvSpPr>
+        <p:spPr>
+          <a:xfrm>
+            <a:off x="6406743" y="2922464"/>
+            <a:ext cx="2197531" cy="983315"/>
+          </a:xfrm>
+          <a:prstGeom prst="rect">
+            <a:avLst/>
+          </a:prstGeom>
+          <a:noFill/>
+        </p:spPr>
+        <p:txBody>
+          <a:bodyPr wrap="square" anchor="t" lIns="0" rIns="0" tIns="0" bIns="0">
+            <a:spAutoFit/>
+          </a:bodyPr>
+          <a:lstStyle/>
+          <a:p>
+            <a:pPr algn="l">
+              <a:lnSpc>
+                <a:spcPct val="102000"/>
+              </a:lnSpc>
+            </a:pPr>
+            <a:r>
+              <a:rPr sz="1050" b="1">
+                <a:solidFill>
+                  <a:srgbClr val="20242C"/>
+                </a:solidFill>
+                <a:latin typeface="Microsoft YaHei"/>
+              </a:rPr>
+              <a:t>代表</a:t>
+            </a:r>
+            <a:r>
+              <a:rPr sz="1050" b="0">
+                <a:solidFill>
+                  <a:srgbClr val="20242C"/>
+                </a:solidFill>
+                <a:latin typeface="Microsoft YaHei"/>
+              </a:rPr>
+              <a:t>：S27。</a:t>
             </a:r>
           </a:p>
           <a:p>
@@ -11280,7 +11421,53 @@
               </a:spcBef>
             </a:pPr>
             <a:r>
-              <a:rPr sz="1200" b="1">
+              <a:rPr sz="1050" b="1">
+                <a:solidFill>
+                  <a:srgbClr val="20242C"/>
+                </a:solidFill>
+                <a:latin typeface="Microsoft YaHei"/>
+              </a:rPr>
+              <a:t>听什么</a:t>
+            </a:r>
+            <a:r>
+              <a:rPr sz="1050" b="0">
+                <a:solidFill>
+                  <a:srgbClr val="20242C"/>
+                </a:solidFill>
+                <a:latin typeface="Microsoft YaHei"/>
+              </a:rPr>
+              <a:t>：hop 占用率，沿邻线上传。</a:t>
+            </a:r>
+          </a:p>
+          <a:p>
+            <a:pPr algn="l">
+              <a:lnSpc>
+                <a:spcPct val="102000"/>
+              </a:lnSpc>
+              <a:spcBef>
+                <a:spcPts val="600"/>
+              </a:spcBef>
+            </a:pPr>
+            <a:r>
+              <a:rPr sz="1050" b="1">
+                <a:solidFill>
+                  <a:srgbClr val="20242C"/>
+                </a:solidFill>
+                <a:latin typeface="Microsoft YaHei"/>
+              </a:rPr>
+              <a:t>优</a:t>
+            </a:r>
+            <a:r>
+              <a:rPr sz="1050" b="0">
+                <a:solidFill>
+                  <a:srgbClr val="20242C"/>
+                </a:solidFill>
+                <a:latin typeface="Microsoft YaHei"/>
+              </a:rPr>
+              <a:t>：信号就在拥塞 hop。</a:t>
+            </a:r>
+            <a:r>
+              <a:rPr sz="1050" b="1">
                 <a:solidFill>
                   <a:srgbClr val="20242C"/>
                 </a:solidFill>
@@ -11289,27 +11476,441 @@
               <a:t>缺</a:t>
             </a:r>
             <a:r>
-              <a:rPr sz="1200" b="0">
-                <a:solidFill>
-                  <a:srgbClr val="20242C"/>
-                </a:solidFill>
-                <a:latin typeface="Microsoft YaHei"/>
-              </a:rPr>
-              <a:t>：需要可暂停的队列；会形成拥塞树，伤及无辜。</a:t>
-            </a:r>
-          </a:p>
-        </p:txBody>
-      </p:sp>
-      <p:sp>
-        <p:nvSpPr>
-          <p:cNvPr id="16" name="Rectangle 15"/>
+              <a:rPr sz="1050" b="0">
+                <a:solidFill>
+                  <a:srgbClr val="20242C"/>
+                </a:solidFill>
+                <a:latin typeface="Microsoft YaHei"/>
+              </a:rPr>
+              <a:t>：无缓存环上「保护链路」= 空转。</a:t>
+            </a:r>
+          </a:p>
+        </p:txBody>
+      </p:sp>
+      <p:sp>
+        <p:nvSpPr>
+          <p:cNvPr id="19" name="Rectangle 18"/>
           <p:cNvSpPr/>
           <p:nvPr/>
         </p:nvSpPr>
         <p:spPr>
           <a:xfrm>
-            <a:off x="6205575" y="2971083"/>
-            <a:ext cx="2599867" cy="2616616"/>
+            <a:off x="9024899" y="2252814"/>
+            <a:ext cx="2599867" cy="1916849"/>
+          </a:xfrm>
+          <a:prstGeom prst="rect">
+            <a:avLst/>
+          </a:prstGeom>
+          <a:solidFill>
+            <a:srgbClr val="FFFFFF"/>
+          </a:solidFill>
+          <a:ln w="12700">
+            <a:solidFill>
+              <a:srgbClr val="DCE3EA"/>
+            </a:solidFill>
+          </a:ln>
+          <a:effectLst/>
+        </p:spPr>
+        <p:style>
+          <a:lnRef idx="1">
+            <a:schemeClr val="accent1"/>
+          </a:lnRef>
+          <a:fillRef idx="3">
+            <a:schemeClr val="accent1"/>
+          </a:fillRef>
+          <a:effectRef idx="2">
+            <a:schemeClr val="accent1"/>
+          </a:effectRef>
+          <a:fontRef idx="minor">
+            <a:schemeClr val="lt1"/>
+          </a:fontRef>
+        </p:style>
+        <p:txBody>
+          <a:bodyPr rtlCol="0" anchor="ctr" wrap="square"/>
+          <a:lstStyle/>
+          <a:p>
+            <a:pPr algn="ctr"/>
+          </a:p>
+        </p:txBody>
+      </p:sp>
+      <p:sp>
+        <p:nvSpPr>
+          <p:cNvPr id="20" name="TextBox 19"/>
+          <p:cNvSpPr txBox="1"/>
+          <p:nvPr/>
+        </p:nvSpPr>
+        <p:spPr>
+          <a:xfrm>
+            <a:off x="9226067" y="2553275"/>
+            <a:ext cx="2197531" cy="286893"/>
+          </a:xfrm>
+          <a:prstGeom prst="rect">
+            <a:avLst/>
+          </a:prstGeom>
+          <a:noFill/>
+        </p:spPr>
+        <p:txBody>
+          <a:bodyPr wrap="square" anchor="t" lIns="0" rIns="0" tIns="0" bIns="0">
+            <a:spAutoFit/>
+          </a:bodyPr>
+          <a:lstStyle/>
+          <a:p>
+            <a:pPr algn="l">
+              <a:lnSpc>
+                <a:spcPct val="100000"/>
+              </a:lnSpc>
+            </a:pPr>
+            <a:r>
+              <a:rPr sz="1350" b="1">
+                <a:solidFill>
+                  <a:srgbClr val="20242C"/>
+                </a:solidFill>
+                <a:latin typeface="Microsoft YaHei"/>
+              </a:rPr>
+              <a:t>时延</a:t>
+            </a:r>
+          </a:p>
+        </p:txBody>
+      </p:sp>
+      <p:sp>
+        <p:nvSpPr>
+          <p:cNvPr id="21" name="TextBox 20"/>
+          <p:cNvSpPr txBox="1"/>
+          <p:nvPr/>
+        </p:nvSpPr>
+        <p:spPr>
+          <a:xfrm>
+            <a:off x="9226067" y="2922464"/>
+            <a:ext cx="2197531" cy="983315"/>
+          </a:xfrm>
+          <a:prstGeom prst="rect">
+            <a:avLst/>
+          </a:prstGeom>
+          <a:noFill/>
+        </p:spPr>
+        <p:txBody>
+          <a:bodyPr wrap="square" anchor="t" lIns="0" rIns="0" tIns="0" bIns="0">
+            <a:spAutoFit/>
+          </a:bodyPr>
+          <a:lstStyle/>
+          <a:p>
+            <a:pPr algn="l">
+              <a:lnSpc>
+                <a:spcPct val="102000"/>
+              </a:lnSpc>
+            </a:pPr>
+            <a:r>
+              <a:rPr sz="1050" b="1">
+                <a:solidFill>
+                  <a:srgbClr val="20242C"/>
+                </a:solidFill>
+                <a:latin typeface="Microsoft YaHei"/>
+              </a:rPr>
+              <a:t>代表</a:t>
+            </a:r>
+            <a:r>
+              <a:rPr sz="1050" b="0">
+                <a:solidFill>
+                  <a:srgbClr val="20242C"/>
+                </a:solidFill>
+                <a:latin typeface="Microsoft YaHei"/>
+              </a:rPr>
+              <a:t>：S17 / S19。</a:t>
+            </a:r>
+          </a:p>
+          <a:p>
+            <a:pPr algn="l">
+              <a:lnSpc>
+                <a:spcPct val="102000"/>
+              </a:lnSpc>
+              <a:spcBef>
+                <a:spcPts val="600"/>
+              </a:spcBef>
+            </a:pPr>
+            <a:r>
+              <a:rPr sz="1050" b="1">
+                <a:solidFill>
+                  <a:srgbClr val="20242C"/>
+                </a:solidFill>
+                <a:latin typeface="Microsoft YaHei"/>
+              </a:rPr>
+              <a:t>听什么</a:t>
+            </a:r>
+            <a:r>
+              <a:rPr sz="1050" b="0">
+                <a:solidFill>
+                  <a:srgbClr val="20242C"/>
+                </a:solidFill>
+                <a:latin typeface="Microsoft YaHei"/>
+              </a:rPr>
+              <a:t>：带内 RTT（Comp 回程）。</a:t>
+            </a:r>
+          </a:p>
+          <a:p>
+            <a:pPr algn="l">
+              <a:lnSpc>
+                <a:spcPct val="102000"/>
+              </a:lnSpc>
+              <a:spcBef>
+                <a:spcPts val="600"/>
+              </a:spcBef>
+            </a:pPr>
+            <a:r>
+              <a:rPr sz="1050" b="1">
+                <a:solidFill>
+                  <a:srgbClr val="20242C"/>
+                </a:solidFill>
+                <a:latin typeface="Microsoft YaHei"/>
+              </a:rPr>
+              <a:t>优</a:t>
+            </a:r>
+            <a:r>
+              <a:rPr sz="1050" b="0">
+                <a:solidFill>
+                  <a:srgbClr val="20242C"/>
+                </a:solidFill>
+                <a:latin typeface="Microsoft YaHei"/>
+              </a:rPr>
+              <a:t>：不需要专用总线。</a:t>
+            </a:r>
+            <a:r>
+              <a:rPr sz="1050" b="1">
+                <a:solidFill>
+                  <a:srgbClr val="20242C"/>
+                </a:solidFill>
+                <a:latin typeface="Microsoft YaHei"/>
+              </a:rPr>
+              <a:t>缺</a:t>
+            </a:r>
+            <a:r>
+              <a:rPr sz="1050" b="0">
+                <a:solidFill>
+                  <a:srgbClr val="20242C"/>
+                </a:solidFill>
+                <a:latin typeface="Microsoft YaHei"/>
+              </a:rPr>
+              <a:t>：无缓存环几乎没有排队时延。</a:t>
+            </a:r>
+          </a:p>
+        </p:txBody>
+      </p:sp>
+      <p:sp>
+        <p:nvSpPr>
+          <p:cNvPr id="22" name="Rectangle 21"/>
+          <p:cNvSpPr/>
+          <p:nvPr/>
+        </p:nvSpPr>
+        <p:spPr>
+          <a:xfrm>
+            <a:off x="566928" y="4389120"/>
+            <a:ext cx="2599867" cy="1916849"/>
+          </a:xfrm>
+          <a:prstGeom prst="rect">
+            <a:avLst/>
+          </a:prstGeom>
+          <a:solidFill>
+            <a:srgbClr val="FFFFFF"/>
+          </a:solidFill>
+          <a:ln w="12700">
+            <a:solidFill>
+              <a:srgbClr val="DCE3EA"/>
+            </a:solidFill>
+          </a:ln>
+          <a:effectLst/>
+        </p:spPr>
+        <p:style>
+          <a:lnRef idx="1">
+            <a:schemeClr val="accent1"/>
+          </a:lnRef>
+          <a:fillRef idx="3">
+            <a:schemeClr val="accent1"/>
+          </a:fillRef>
+          <a:effectRef idx="2">
+            <a:schemeClr val="accent1"/>
+          </a:effectRef>
+          <a:fontRef idx="minor">
+            <a:schemeClr val="lt1"/>
+          </a:fontRef>
+        </p:style>
+        <p:txBody>
+          <a:bodyPr rtlCol="0" anchor="ctr" wrap="square"/>
+          <a:lstStyle/>
+          <a:p>
+            <a:pPr algn="ctr"/>
+          </a:p>
+        </p:txBody>
+      </p:sp>
+      <p:sp>
+        <p:nvSpPr>
+          <p:cNvPr id="23" name="TextBox 22"/>
+          <p:cNvSpPr txBox="1"/>
+          <p:nvPr/>
+        </p:nvSpPr>
+        <p:spPr>
+          <a:xfrm>
+            <a:off x="768096" y="4689580"/>
+            <a:ext cx="2197531" cy="286893"/>
+          </a:xfrm>
+          <a:prstGeom prst="rect">
+            <a:avLst/>
+          </a:prstGeom>
+          <a:noFill/>
+        </p:spPr>
+        <p:txBody>
+          <a:bodyPr wrap="square" anchor="t" lIns="0" rIns="0" tIns="0" bIns="0">
+            <a:spAutoFit/>
+          </a:bodyPr>
+          <a:lstStyle/>
+          <a:p>
+            <a:pPr algn="l">
+              <a:lnSpc>
+                <a:spcPct val="100000"/>
+              </a:lnSpc>
+            </a:pPr>
+            <a:r>
+              <a:rPr sz="1350" b="1">
+                <a:solidFill>
+                  <a:srgbClr val="20242C"/>
+                </a:solidFill>
+                <a:latin typeface="Microsoft YaHei"/>
+              </a:rPr>
+              <a:t>ECN 标记</a:t>
+            </a:r>
+          </a:p>
+        </p:txBody>
+      </p:sp>
+      <p:sp>
+        <p:nvSpPr>
+          <p:cNvPr id="24" name="TextBox 23"/>
+          <p:cNvSpPr txBox="1"/>
+          <p:nvPr/>
+        </p:nvSpPr>
+        <p:spPr>
+          <a:xfrm>
+            <a:off x="768096" y="5058769"/>
+            <a:ext cx="2197531" cy="983315"/>
+          </a:xfrm>
+          <a:prstGeom prst="rect">
+            <a:avLst/>
+          </a:prstGeom>
+          <a:noFill/>
+        </p:spPr>
+        <p:txBody>
+          <a:bodyPr wrap="square" anchor="t" lIns="0" rIns="0" tIns="0" bIns="0">
+            <a:spAutoFit/>
+          </a:bodyPr>
+          <a:lstStyle/>
+          <a:p>
+            <a:pPr algn="l">
+              <a:lnSpc>
+                <a:spcPct val="102000"/>
+              </a:lnSpc>
+            </a:pPr>
+            <a:r>
+              <a:rPr sz="1050" b="1">
+                <a:solidFill>
+                  <a:srgbClr val="20242C"/>
+                </a:solidFill>
+                <a:latin typeface="Microsoft YaHei"/>
+              </a:rPr>
+              <a:t>代表</a:t>
+            </a:r>
+            <a:r>
+              <a:rPr sz="1050" b="0">
+                <a:solidFill>
+                  <a:srgbClr val="20242C"/>
+                </a:solidFill>
+                <a:latin typeface="Microsoft YaHei"/>
+              </a:rPr>
+              <a:t>：S18 / S20。</a:t>
+            </a:r>
+          </a:p>
+          <a:p>
+            <a:pPr algn="l">
+              <a:lnSpc>
+                <a:spcPct val="102000"/>
+              </a:lnSpc>
+              <a:spcBef>
+                <a:spcPts val="600"/>
+              </a:spcBef>
+            </a:pPr>
+            <a:r>
+              <a:rPr sz="1050" b="1">
+                <a:solidFill>
+                  <a:srgbClr val="20242C"/>
+                </a:solidFill>
+                <a:latin typeface="Microsoft YaHei"/>
+              </a:rPr>
+              <a:t>听什么</a:t>
+            </a:r>
+            <a:r>
+              <a:rPr sz="1050" b="0">
+                <a:solidFill>
+                  <a:srgbClr val="20242C"/>
+                </a:solidFill>
+                <a:latin typeface="Microsoft YaHei"/>
+              </a:rPr>
+              <a:t>：RSP 上的一比特标记。</a:t>
+            </a:r>
+          </a:p>
+          <a:p>
+            <a:pPr algn="l">
+              <a:lnSpc>
+                <a:spcPct val="102000"/>
+              </a:lnSpc>
+              <a:spcBef>
+                <a:spcPts val="600"/>
+              </a:spcBef>
+            </a:pPr>
+            <a:r>
+              <a:rPr sz="1050" b="1">
+                <a:solidFill>
+                  <a:srgbClr val="20242C"/>
+                </a:solidFill>
+                <a:latin typeface="Microsoft YaHei"/>
+              </a:rPr>
+              <a:t>优</a:t>
+            </a:r>
+            <a:r>
+              <a:rPr sz="1050" b="0">
+                <a:solidFill>
+                  <a:srgbClr val="20242C"/>
+                </a:solidFill>
+                <a:latin typeface="Microsoft YaHei"/>
+              </a:rPr>
+              <a:t>：复用已有通道。</a:t>
+            </a:r>
+            <a:r>
+              <a:rPr sz="1050" b="1">
+                <a:solidFill>
+                  <a:srgbClr val="20242C"/>
+                </a:solidFill>
+                <a:latin typeface="Microsoft YaHei"/>
+              </a:rPr>
+              <a:t>缺</a:t>
+            </a:r>
+            <a:r>
+              <a:rPr sz="1050" b="0">
+                <a:solidFill>
+                  <a:srgbClr val="20242C"/>
+                </a:solidFill>
+                <a:latin typeface="Microsoft YaHei"/>
+              </a:rPr>
+              <a:t>：标记仍来自本节点失败。</a:t>
+            </a:r>
+          </a:p>
+        </p:txBody>
+      </p:sp>
+      <p:sp>
+        <p:nvSpPr>
+          <p:cNvPr id="25" name="Rectangle 24"/>
+          <p:cNvSpPr/>
+          <p:nvPr/>
+        </p:nvSpPr>
+        <p:spPr>
+          <a:xfrm>
+            <a:off x="3386251" y="4389120"/>
+            <a:ext cx="2599867" cy="1916849"/>
           </a:xfrm>
           <a:prstGeom prst="rect">
             <a:avLst/>
@@ -11348,14 +11949,14 @@
       </p:sp>
       <p:sp>
         <p:nvSpPr>
-          <p:cNvPr id="17" name="TextBox 16"/>
-          <p:cNvSpPr txBox="1"/>
-          <p:nvPr/>
-        </p:nvSpPr>
-        <p:spPr>
-          <a:xfrm>
-            <a:off x="6406743" y="3172251"/>
-            <a:ext cx="2197531" cy="314705"/>
+          <p:cNvPr id="26" name="TextBox 25"/>
+          <p:cNvSpPr txBox="1"/>
+          <p:nvPr/>
+        </p:nvSpPr>
+        <p:spPr>
+          <a:xfrm>
+            <a:off x="3587419" y="4590288"/>
+            <a:ext cx="2197531" cy="286893"/>
           </a:xfrm>
           <a:prstGeom prst="rect">
             <a:avLst/>
@@ -11374,27 +11975,27 @@
               </a:lnSpc>
             </a:pPr>
             <a:r>
-              <a:rPr sz="1500" b="1">
+              <a:rPr sz="1350" b="1">
                 <a:solidFill>
                   <a:srgbClr val="D20A2E"/>
                 </a:solidFill>
                 <a:latin typeface="Microsoft YaHei"/>
               </a:rPr>
-              <a:t>③ 源端限速 · 速率型</a:t>
-            </a:r>
-          </a:p>
-        </p:txBody>
-      </p:sp>
-      <p:sp>
-        <p:nvSpPr>
-          <p:cNvPr id="18" name="TextBox 17"/>
-          <p:cNvSpPr txBox="1"/>
-          <p:nvPr/>
-        </p:nvSpPr>
-        <p:spPr>
-          <a:xfrm>
-            <a:off x="6406743" y="3569253"/>
-            <a:ext cx="2197531" cy="1853854"/>
+              <a:t>显式等级</a:t>
+            </a:r>
+          </a:p>
+        </p:txBody>
+      </p:sp>
+      <p:sp>
+        <p:nvSpPr>
+          <p:cNvPr id="27" name="TextBox 26"/>
+          <p:cNvSpPr txBox="1"/>
+          <p:nvPr/>
+        </p:nvSpPr>
+        <p:spPr>
+          <a:xfrm>
+            <a:off x="3587419" y="4959477"/>
+            <a:ext cx="2197531" cy="1181900"/>
           </a:xfrm>
           <a:prstGeom prst="rect">
             <a:avLst/>
@@ -11413,7 +12014,7 @@
               </a:lnSpc>
             </a:pPr>
             <a:r>
-              <a:rPr sz="1200" b="1">
+              <a:rPr sz="1050" b="1">
                 <a:solidFill>
                   <a:srgbClr val="20242C"/>
                 </a:solidFill>
@@ -11422,13 +12023,13 @@
               <a:t>代表</a:t>
             </a:r>
             <a:r>
-              <a:rPr sz="1200" b="0">
-                <a:solidFill>
-                  <a:srgbClr val="20242C"/>
-                </a:solidFill>
-                <a:latin typeface="Microsoft YaHei"/>
-              </a:rPr>
-              <a:t>：AIMD / DCQCN / TIMELY / QCN。</a:t>
+              <a:rPr sz="1050" b="0">
+                <a:solidFill>
+                  <a:srgbClr val="20242C"/>
+                </a:solidFill>
+                <a:latin typeface="Microsoft YaHei"/>
+              </a:rPr>
+              <a:t>：S1 / S1T / S15 / S22。</a:t>
             </a:r>
           </a:p>
           <a:p>
@@ -11441,22 +12042,22 @@
               </a:spcBef>
             </a:pPr>
             <a:r>
-              <a:rPr sz="1200" b="1">
-                <a:solidFill>
-                  <a:srgbClr val="20242C"/>
-                </a:solidFill>
-                <a:latin typeface="Microsoft YaHei"/>
-              </a:rPr>
-              <a:t>动手处</a:t>
-            </a:r>
-            <a:r>
-              <a:rPr sz="1200" b="0">
-                <a:solidFill>
-                  <a:srgbClr val="20242C"/>
-                </a:solidFill>
-                <a:latin typeface="Microsoft YaHei"/>
-              </a:rPr>
-              <a:t>：注入令牌桶。</a:t>
+              <a:rPr sz="1050" b="1">
+                <a:solidFill>
+                  <a:srgbClr val="20242C"/>
+                </a:solidFill>
+                <a:latin typeface="Microsoft YaHei"/>
+              </a:rPr>
+              <a:t>听什么</a:t>
+            </a:r>
+            <a:r>
+              <a:rPr sz="1050" b="0">
+                <a:solidFill>
+                  <a:srgbClr val="20242C"/>
+                </a:solidFill>
+                <a:latin typeface="Microsoft YaHei"/>
+              </a:rPr>
+              <a:t>：广播的拥塞等级或进度。</a:t>
             </a:r>
           </a:p>
           <a:p>
@@ -11469,7 +12070,7 @@
               </a:spcBef>
             </a:pPr>
             <a:r>
-              <a:rPr sz="1200" b="1">
+              <a:rPr sz="1050" b="1">
                 <a:solidFill>
                   <a:srgbClr val="20242C"/>
                 </a:solidFill>
@@ -11478,26 +12079,16 @@
               <a:t>优</a:t>
             </a:r>
             <a:r>
-              <a:rPr sz="1200" b="0">
-                <a:solidFill>
-                  <a:srgbClr val="20242C"/>
-                </a:solidFill>
-                <a:latin typeface="Microsoft YaHei"/>
-              </a:rPr>
-              <a:t>：直接控制注入总量，稳定性有成熟理论，执行器便宜。</a:t>
-            </a:r>
-          </a:p>
-          <a:p>
-            <a:pPr algn="l">
-              <a:lnSpc>
-                <a:spcPct val="102000"/>
-              </a:lnSpc>
-              <a:spcBef>
-                <a:spcPts val="600"/>
-              </a:spcBef>
-            </a:pPr>
-            <a:r>
-              <a:rPr sz="1200" b="1">
+              <a:rPr sz="1050" b="0">
+                <a:solidFill>
+                  <a:srgbClr val="20242C"/>
+                </a:solidFill>
+                <a:latin typeface="Microsoft YaHei"/>
+              </a:rPr>
+              <a:t>：全局可见。</a:t>
+            </a:r>
+            <a:r>
+              <a:rPr sz="1050" b="1">
                 <a:solidFill>
                   <a:srgbClr val="20242C"/>
                 </a:solidFill>
@@ -11506,27 +12097,27 @@
               <a:t>缺</a:t>
             </a:r>
             <a:r>
-              <a:rPr sz="1200" b="0">
-                <a:solidFill>
-                  <a:srgbClr val="20242C"/>
-                </a:solidFill>
-                <a:latin typeface="Microsoft YaHei"/>
-              </a:rPr>
-              <a:t>：闸门只能「扣住」，让出的槽会被沿途吃掉；量化亏带宽。</a:t>
-            </a:r>
-          </a:p>
-        </p:txBody>
-      </p:sp>
-      <p:sp>
-        <p:nvSpPr>
-          <p:cNvPr id="19" name="Rectangle 18"/>
+              <a:rPr sz="1050" b="0">
+                <a:solidFill>
+                  <a:srgbClr val="20242C"/>
+                </a:solidFill>
+                <a:latin typeface="Microsoft YaHei"/>
+              </a:rPr>
+              <a:t>：分不清「我太贪」和「我被挤」；S22 只换了线上内容。</a:t>
+            </a:r>
+          </a:p>
+        </p:txBody>
+      </p:sp>
+      <p:sp>
+        <p:nvSpPr>
+          <p:cNvPr id="28" name="Rectangle 27"/>
           <p:cNvSpPr/>
           <p:nvPr/>
         </p:nvSpPr>
         <p:spPr>
           <a:xfrm>
-            <a:off x="9024899" y="2971083"/>
-            <a:ext cx="2599867" cy="2616616"/>
+            <a:off x="6205575" y="4389120"/>
+            <a:ext cx="2599867" cy="1916849"/>
           </a:xfrm>
           <a:prstGeom prst="rect">
             <a:avLst/>
@@ -11565,14 +12156,14 @@
       </p:sp>
       <p:sp>
         <p:nvSpPr>
-          <p:cNvPr id="20" name="TextBox 19"/>
-          <p:cNvSpPr txBox="1"/>
-          <p:nvPr/>
-        </p:nvSpPr>
-        <p:spPr>
-          <a:xfrm>
-            <a:off x="9226067" y="3172251"/>
-            <a:ext cx="2197531" cy="314705"/>
+          <p:cNvPr id="29" name="TextBox 28"/>
+          <p:cNvSpPr txBox="1"/>
+          <p:nvPr/>
+        </p:nvSpPr>
+        <p:spPr>
+          <a:xfrm>
+            <a:off x="6406743" y="4689580"/>
+            <a:ext cx="2197531" cy="286893"/>
           </a:xfrm>
           <a:prstGeom prst="rect">
             <a:avLst/>
@@ -11591,27 +12182,27 @@
               </a:lnSpc>
             </a:pPr>
             <a:r>
-              <a:rPr sz="1500" b="1">
-                <a:solidFill>
-                  <a:srgbClr val="20242C"/>
-                </a:solidFill>
-                <a:latin typeface="Microsoft YaHei"/>
-              </a:rPr>
-              <a:t>④ 源端限速 · 窗口型</a:t>
-            </a:r>
-          </a:p>
-        </p:txBody>
-      </p:sp>
-      <p:sp>
-        <p:nvSpPr>
-          <p:cNvPr id="21" name="TextBox 20"/>
-          <p:cNvSpPr txBox="1"/>
-          <p:nvPr/>
-        </p:nvSpPr>
-        <p:spPr>
-          <a:xfrm>
-            <a:off x="9226067" y="3569253"/>
-            <a:ext cx="2197531" cy="1853854"/>
+              <a:rPr sz="1350" b="1">
+                <a:solidFill>
+                  <a:srgbClr val="20242C"/>
+                </a:solidFill>
+                <a:latin typeface="Microsoft YaHei"/>
+              </a:rPr>
+              <a:t>显式速率</a:t>
+            </a:r>
+          </a:p>
+        </p:txBody>
+      </p:sp>
+      <p:sp>
+        <p:nvSpPr>
+          <p:cNvPr id="30" name="TextBox 29"/>
+          <p:cNvSpPr txBox="1"/>
+          <p:nvPr/>
+        </p:nvSpPr>
+        <p:spPr>
+          <a:xfrm>
+            <a:off x="6406743" y="5058769"/>
+            <a:ext cx="2197531" cy="983315"/>
           </a:xfrm>
           <a:prstGeom prst="rect">
             <a:avLst/>
@@ -11630,7 +12221,7 @@
               </a:lnSpc>
             </a:pPr>
             <a:r>
-              <a:rPr sz="1200" b="1">
+              <a:rPr sz="1050" b="1">
                 <a:solidFill>
                   <a:srgbClr val="20242C"/>
                 </a:solidFill>
@@ -11639,13 +12230,13 @@
               <a:t>代表</a:t>
             </a:r>
             <a:r>
-              <a:rPr sz="1200" b="0">
-                <a:solidFill>
-                  <a:srgbClr val="20242C"/>
-                </a:solidFill>
-                <a:latin typeface="Microsoft YaHei"/>
-              </a:rPr>
-              <a:t>：TCP / DCTCP / Swift / outstanding cap。</a:t>
+              <a:rPr sz="1050" b="0">
+                <a:solidFill>
+                  <a:srgbClr val="20242C"/>
+                </a:solidFill>
+                <a:latin typeface="Microsoft YaHei"/>
+              </a:rPr>
+              <a:t>：S28 / S28S。</a:t>
             </a:r>
           </a:p>
           <a:p>
@@ -11658,22 +12249,22 @@
               </a:spcBef>
             </a:pPr>
             <a:r>
-              <a:rPr sz="1200" b="1">
-                <a:solidFill>
-                  <a:srgbClr val="20242C"/>
-                </a:solidFill>
-                <a:latin typeface="Microsoft YaHei"/>
-              </a:rPr>
-              <a:t>动手处</a:t>
-            </a:r>
-            <a:r>
-              <a:rPr sz="1200" b="0">
-                <a:solidFill>
-                  <a:srgbClr val="20242C"/>
-                </a:solidFill>
-                <a:latin typeface="Microsoft YaHei"/>
-              </a:rPr>
-              <a:t>：在飞事务数。</a:t>
+              <a:rPr sz="1050" b="1">
+                <a:solidFill>
+                  <a:srgbClr val="20242C"/>
+                </a:solidFill>
+                <a:latin typeface="Microsoft YaHei"/>
+              </a:rPr>
+              <a:t>听什么</a:t>
+            </a:r>
+            <a:r>
+              <a:rPr sz="1050" b="0">
+                <a:solidFill>
+                  <a:srgbClr val="20242C"/>
+                </a:solidFill>
+                <a:latin typeface="Microsoft YaHei"/>
+              </a:rPr>
+              <a:t>：瓶颈自己算出的 share。</a:t>
             </a:r>
           </a:p>
           <a:p>
@@ -11686,7 +12277,7 @@
               </a:spcBef>
             </a:pPr>
             <a:r>
-              <a:rPr sz="1200" b="1">
+              <a:rPr sz="1050" b="1">
                 <a:solidFill>
                   <a:srgbClr val="20242C"/>
                 </a:solidFill>
@@ -11695,26 +12286,16 @@
               <a:t>优</a:t>
             </a:r>
             <a:r>
-              <a:rPr sz="1200" b="0">
-                <a:solidFill>
-                  <a:srgbClr val="20242C"/>
-                </a:solidFill>
-                <a:latin typeface="Microsoft YaHei"/>
-              </a:rPr>
-              <a:t>：与 CHI 事务模型天然对齐；有名额可突发，不做逐拍量化。</a:t>
-            </a:r>
-          </a:p>
-          <a:p>
-            <a:pPr algn="l">
-              <a:lnSpc>
-                <a:spcPct val="102000"/>
-              </a:lnSpc>
-              <a:spcBef>
-                <a:spcPts val="600"/>
-              </a:spcBef>
-            </a:pPr>
-            <a:r>
-              <a:rPr sz="1200" b="1">
+              <a:rPr sz="1050" b="0">
+                <a:solidFill>
+                  <a:srgbClr val="20242C"/>
+                </a:solidFill>
+                <a:latin typeface="Microsoft YaHei"/>
+              </a:rPr>
+              <a:t>：源端不必猜。</a:t>
+            </a:r>
+            <a:r>
+              <a:rPr sz="1050" b="1">
                 <a:solidFill>
                   <a:srgbClr val="20242C"/>
                 </a:solidFill>
@@ -11723,20 +12304,20 @@
               <a:t>缺</a:t>
             </a:r>
             <a:r>
-              <a:rPr sz="1200" b="0">
-                <a:solidFill>
-                  <a:srgbClr val="20242C"/>
-                </a:solidFill>
-                <a:latin typeface="Microsoft YaHei"/>
-              </a:rPr>
-              <a:t>：只管「有多少在飞」，不决定「瓶颈处先服务谁」。</a:t>
-            </a:r>
-          </a:p>
-        </p:txBody>
-      </p:sp>
-      <p:sp>
-        <p:nvSpPr>
-          <p:cNvPr id="22" name="TextBox 21"/>
+              <a:rPr sz="1050" b="0">
+                <a:solidFill>
+                  <a:srgbClr val="20242C"/>
+                </a:solidFill>
+                <a:latin typeface="Microsoft YaHei"/>
+              </a:rPr>
+              <a:t>：总线最宽；不公平不在 hop 份额。</a:t>
+            </a:r>
+          </a:p>
+        </p:txBody>
+      </p:sp>
+      <p:sp>
+        <p:nvSpPr>
+          <p:cNvPr id="31" name="TextBox 30"/>
           <p:cNvSpPr txBox="1"/>
           <p:nvPr/>
         </p:nvSpPr>
@@ -11913,7 +12494,7 @@
                 </a:solidFill>
                 <a:latin typeface="Microsoft YaHei"/>
               </a:rPr>
-              <a:t>分类 · 控制点 ⑤–⑧</a:t>
+              <a:t>分类 · 控制点（第 19 页的列）</a:t>
             </a:r>
           </a:p>
         </p:txBody>
@@ -12079,7 +12660,7 @@
                 </a:solidFill>
                 <a:latin typeface="Arial"/>
               </a:rPr>
-              <a:t>T A X O N O M Y   B Y   C O N T R O L   P O I N T   ·   2   /   2</a:t>
+              <a:t>T A X O N O M Y   B Y   C O N T R O L   P O I N T     =     P A G E   1 9   C O L S</a:t>
             </a:r>
           </a:p>
         </p:txBody>
@@ -12118,7 +12699,7 @@
                 </a:solidFill>
                 <a:latin typeface="Microsoft YaHei"/>
               </a:rPr>
-              <a:t>其余四类：把控制点从源端搬到网内、接收端或调度器</a:t>
+              <a:t>动手处决定天花板（= 第 19 页的列）</a:t>
             </a:r>
           </a:p>
         </p:txBody>
@@ -12131,8 +12712,8 @@
         </p:nvSpPr>
         <p:spPr>
           <a:xfrm>
-            <a:off x="566928" y="2422443"/>
-            <a:ext cx="2599867" cy="2616616"/>
+            <a:off x="566928" y="2252814"/>
+            <a:ext cx="2599867" cy="1916849"/>
           </a:xfrm>
           <a:prstGeom prst="rect">
             <a:avLst/>
@@ -12177,8 +12758,8 @@
         </p:nvSpPr>
         <p:spPr>
           <a:xfrm>
-            <a:off x="768096" y="2623611"/>
-            <a:ext cx="2197531" cy="314705"/>
+            <a:off x="768096" y="2553275"/>
+            <a:ext cx="2197531" cy="286893"/>
           </a:xfrm>
           <a:prstGeom prst="rect">
             <a:avLst/>
@@ -12197,13 +12778,13 @@
               </a:lnSpc>
             </a:pPr>
             <a:r>
-              <a:rPr sz="1500" b="1">
-                <a:solidFill>
-                  <a:srgbClr val="20242C"/>
-                </a:solidFill>
-                <a:latin typeface="Microsoft YaHei"/>
-              </a:rPr>
-              <a:t>⑤ 网内仲裁 / 公平队列</a:t>
+              <a:rPr sz="1350" b="1">
+                <a:solidFill>
+                  <a:srgbClr val="20242C"/>
+                </a:solidFill>
+                <a:latin typeface="Microsoft YaHei"/>
+              </a:rPr>
+              <a:t>路径选择</a:t>
             </a:r>
           </a:p>
         </p:txBody>
@@ -12216,8 +12797,8 @@
         </p:nvSpPr>
         <p:spPr>
           <a:xfrm>
-            <a:off x="768096" y="3020613"/>
-            <a:ext cx="2197531" cy="1853854"/>
+            <a:off x="768096" y="2922464"/>
+            <a:ext cx="2197531" cy="983315"/>
           </a:xfrm>
           <a:prstGeom prst="rect">
             <a:avLst/>
@@ -12236,7 +12817,7 @@
               </a:lnSpc>
             </a:pPr>
             <a:r>
-              <a:rPr sz="1200" b="1">
+              <a:rPr sz="1050" b="1">
                 <a:solidFill>
                   <a:srgbClr val="20242C"/>
                 </a:solidFill>
@@ -12245,13 +12826,13 @@
               <a:t>代表</a:t>
             </a:r>
             <a:r>
-              <a:rPr sz="1200" b="0">
-                <a:solidFill>
-                  <a:srgbClr val="20242C"/>
-                </a:solidFill>
-                <a:latin typeface="Microsoft YaHei"/>
-              </a:rPr>
-              <a:t>：WFQ / age-based arb / iSLIP / HiRD / I-tag。</a:t>
+              <a:rPr sz="1050" b="0">
+                <a:solidFill>
+                  <a:srgbClr val="20242C"/>
+                </a:solidFill>
+                <a:latin typeface="Microsoft YaHei"/>
+              </a:rPr>
+              <a:t>：S26（UGAL / Valiant 类）。</a:t>
             </a:r>
           </a:p>
           <a:p>
@@ -12264,7 +12845,7 @@
               </a:spcBef>
             </a:pPr>
             <a:r>
-              <a:rPr sz="1200" b="1">
+              <a:rPr sz="1050" b="1">
                 <a:solidFill>
                   <a:srgbClr val="20242C"/>
                 </a:solidFill>
@@ -12273,13 +12854,13 @@
               <a:t>动手处</a:t>
             </a:r>
             <a:r>
-              <a:rPr sz="1200" b="0">
-                <a:solidFill>
-                  <a:srgbClr val="20242C"/>
-                </a:solidFill>
-                <a:latin typeface="Microsoft YaHei"/>
-              </a:rPr>
-              <a:t>：环上仲裁。</a:t>
+              <a:rPr sz="1050" b="0">
+                <a:solidFill>
+                  <a:srgbClr val="20242C"/>
+                </a:solidFill>
+                <a:latin typeface="Microsoft YaHei"/>
+              </a:rPr>
+              <a:t>：选最短还是绕远。</a:t>
             </a:r>
           </a:p>
           <a:p>
@@ -12292,7 +12873,7 @@
               </a:spcBef>
             </a:pPr>
             <a:r>
-              <a:rPr sz="1200" b="1">
+              <a:rPr sz="1050" b="1">
                 <a:solidFill>
                   <a:srgbClr val="20242C"/>
                 </a:solidFill>
@@ -12301,26 +12882,16 @@
               <a:t>优</a:t>
             </a:r>
             <a:r>
-              <a:rPr sz="1200" b="0">
-                <a:solidFill>
-                  <a:srgbClr val="20242C"/>
-                </a:solidFill>
-                <a:latin typeface="Microsoft YaHei"/>
-              </a:rPr>
-              <a:t>：控制点就在拥塞发生地，不需要端到端环路，不扣住流量。</a:t>
-            </a:r>
-          </a:p>
-          <a:p>
-            <a:pPr algn="l">
-              <a:lnSpc>
-                <a:spcPct val="102000"/>
-              </a:lnSpc>
-              <a:spcBef>
-                <a:spcPts val="600"/>
-              </a:spcBef>
-            </a:pPr>
-            <a:r>
-              <a:rPr sz="1200" b="1">
+              <a:rPr sz="1050" b="0">
+                <a:solidFill>
+                  <a:srgbClr val="20242C"/>
+                </a:solidFill>
+                <a:latin typeface="Microsoft YaHei"/>
+              </a:rPr>
+              <a:t>：不扣注入量。</a:t>
+            </a:r>
+            <a:r>
+              <a:rPr sz="1050" b="1">
                 <a:solidFill>
                   <a:srgbClr val="20242C"/>
                 </a:solidFill>
@@ -12329,13 +12900,13 @@
               <a:t>缺</a:t>
             </a:r>
             <a:r>
-              <a:rPr sz="1200" b="0">
-                <a:solidFill>
-                  <a:srgbClr val="20242C"/>
-                </a:solidFill>
-                <a:latin typeface="Microsoft YaHei"/>
-              </a:rPr>
-              <a:t>：只能改「这一拍谁先用」，要动仲裁器。</a:t>
+              <a:rPr sz="1050" b="0">
+                <a:solidFill>
+                  <a:srgbClr val="20242C"/>
+                </a:solidFill>
+                <a:latin typeface="Microsoft YaHei"/>
+              </a:rPr>
+              <a:t>：绕远本身要多占链路。</a:t>
             </a:r>
           </a:p>
         </p:txBody>
@@ -12348,8 +12919,8 @@
         </p:nvSpPr>
         <p:spPr>
           <a:xfrm>
-            <a:off x="3386251" y="2422443"/>
-            <a:ext cx="2599867" cy="2616616"/>
+            <a:off x="3386251" y="2252814"/>
+            <a:ext cx="2599867" cy="1916849"/>
           </a:xfrm>
           <a:prstGeom prst="rect">
             <a:avLst/>
@@ -12394,8 +12965,8 @@
         </p:nvSpPr>
         <p:spPr>
           <a:xfrm>
-            <a:off x="3587419" y="2623611"/>
-            <a:ext cx="2197531" cy="314705"/>
+            <a:off x="3587419" y="2553275"/>
+            <a:ext cx="2197531" cy="286893"/>
           </a:xfrm>
           <a:prstGeom prst="rect">
             <a:avLst/>
@@ -12414,13 +12985,13 @@
               </a:lnSpc>
             </a:pPr>
             <a:r>
-              <a:rPr sz="1500" b="1">
-                <a:solidFill>
-                  <a:srgbClr val="20242C"/>
-                </a:solidFill>
-                <a:latin typeface="Microsoft YaHei"/>
-              </a:rPr>
-              <a:t>⑥ 预约 / 调度式准入</a:t>
+              <a:rPr sz="1350" b="1">
+                <a:solidFill>
+                  <a:srgbClr val="20242C"/>
+                </a:solidFill>
+                <a:latin typeface="Microsoft YaHei"/>
+              </a:rPr>
+              <a:t>逐跳背压</a:t>
             </a:r>
           </a:p>
         </p:txBody>
@@ -12433,8 +13004,8 @@
         </p:nvSpPr>
         <p:spPr>
           <a:xfrm>
-            <a:off x="3587419" y="3020613"/>
-            <a:ext cx="2197531" cy="1853854"/>
+            <a:off x="3587419" y="2922464"/>
+            <a:ext cx="2197531" cy="983315"/>
           </a:xfrm>
           <a:prstGeom prst="rect">
             <a:avLst/>
@@ -12453,7 +13024,7 @@
               </a:lnSpc>
             </a:pPr>
             <a:r>
-              <a:rPr sz="1200" b="1">
+              <a:rPr sz="1050" b="1">
                 <a:solidFill>
                   <a:srgbClr val="20242C"/>
                 </a:solidFill>
@@ -12462,13 +13033,13 @@
               <a:t>代表</a:t>
             </a:r>
             <a:r>
-              <a:rPr sz="1200" b="0">
-                <a:solidFill>
-                  <a:srgbClr val="20242C"/>
-                </a:solidFill>
-                <a:latin typeface="Microsoft YaHei"/>
-              </a:rPr>
-              <a:t>：Fastpass / ExpressPass / TDMA / token ring。</a:t>
+              <a:rPr sz="1050" b="0">
+                <a:solidFill>
+                  <a:srgbClr val="20242C"/>
+                </a:solidFill>
+                <a:latin typeface="Microsoft YaHei"/>
+              </a:rPr>
+              <a:t>：S27（PFC / wormhole 类）。</a:t>
             </a:r>
           </a:p>
           <a:p>
@@ -12481,7 +13052,7 @@
               </a:spcBef>
             </a:pPr>
             <a:r>
-              <a:rPr sz="1200" b="1">
+              <a:rPr sz="1050" b="1">
                 <a:solidFill>
                   <a:srgbClr val="20242C"/>
                 </a:solidFill>
@@ -12490,13 +13061,13 @@
               <a:t>动手处</a:t>
             </a:r>
             <a:r>
-              <a:rPr sz="1200" b="0">
-                <a:solidFill>
-                  <a:srgbClr val="20242C"/>
-                </a:solidFill>
-                <a:latin typeface="Microsoft YaHei"/>
-              </a:rPr>
-              <a:t>：预分配时隙。</a:t>
+              <a:rPr sz="1050" b="0">
+                <a:solidFill>
+                  <a:srgbClr val="20242C"/>
+                </a:solidFill>
+                <a:latin typeface="Microsoft YaHei"/>
+              </a:rPr>
+              <a:t>：上游链路 XOFF。</a:t>
             </a:r>
           </a:p>
           <a:p>
@@ -12509,7 +13080,7 @@
               </a:spcBef>
             </a:pPr>
             <a:r>
-              <a:rPr sz="1200" b="1">
+              <a:rPr sz="1050" b="1">
                 <a:solidFill>
                   <a:srgbClr val="20242C"/>
                 </a:solidFill>
@@ -12518,13 +13089,164 @@
               <a:t>优</a:t>
             </a:r>
             <a:r>
-              <a:rPr sz="1200" b="0">
-                <a:solidFill>
-                  <a:srgbClr val="20242C"/>
-                </a:solidFill>
-                <a:latin typeface="Microsoft YaHei"/>
-              </a:rPr>
-              <a:t>：拥塞不形成；最坏情况是调度性质，不是控制环路性质。</a:t>
+              <a:rPr sz="1050" b="0">
+                <a:solidFill>
+                  <a:srgbClr val="20242C"/>
+                </a:solidFill>
+                <a:latin typeface="Microsoft YaHei"/>
+              </a:rPr>
+              <a:t>：不丢包，实现最简单。</a:t>
+            </a:r>
+            <a:r>
+              <a:rPr sz="1050" b="1">
+                <a:solidFill>
+                  <a:srgbClr val="20242C"/>
+                </a:solidFill>
+                <a:latin typeface="Microsoft YaHei"/>
+              </a:rPr>
+              <a:t>缺</a:t>
+            </a:r>
+            <a:r>
+              <a:rPr sz="1050" b="0">
+                <a:solidFill>
+                  <a:srgbClr val="20242C"/>
+                </a:solidFill>
+                <a:latin typeface="Microsoft YaHei"/>
+              </a:rPr>
+              <a:t>：需要可暂停队列，会形成拥塞树。</a:t>
+            </a:r>
+          </a:p>
+        </p:txBody>
+      </p:sp>
+      <p:sp>
+        <p:nvSpPr>
+          <p:cNvPr id="16" name="Rectangle 15"/>
+          <p:cNvSpPr/>
+          <p:nvPr/>
+        </p:nvSpPr>
+        <p:spPr>
+          <a:xfrm>
+            <a:off x="6205575" y="2252814"/>
+            <a:ext cx="2599867" cy="1916849"/>
+          </a:xfrm>
+          <a:prstGeom prst="rect">
+            <a:avLst/>
+          </a:prstGeom>
+          <a:solidFill>
+            <a:srgbClr val="FFFFFF"/>
+          </a:solidFill>
+          <a:ln w="19050">
+            <a:solidFill>
+              <a:srgbClr val="D20A2E"/>
+            </a:solidFill>
+          </a:ln>
+          <a:effectLst/>
+        </p:spPr>
+        <p:style>
+          <a:lnRef idx="1">
+            <a:schemeClr val="accent1"/>
+          </a:lnRef>
+          <a:fillRef idx="3">
+            <a:schemeClr val="accent1"/>
+          </a:fillRef>
+          <a:effectRef idx="2">
+            <a:schemeClr val="accent1"/>
+          </a:effectRef>
+          <a:fontRef idx="minor">
+            <a:schemeClr val="lt1"/>
+          </a:fontRef>
+        </p:style>
+        <p:txBody>
+          <a:bodyPr rtlCol="0" anchor="ctr" wrap="square"/>
+          <a:lstStyle/>
+          <a:p>
+            <a:pPr algn="ctr"/>
+          </a:p>
+        </p:txBody>
+      </p:sp>
+      <p:sp>
+        <p:nvSpPr>
+          <p:cNvPr id="17" name="TextBox 16"/>
+          <p:cNvSpPr txBox="1"/>
+          <p:nvPr/>
+        </p:nvSpPr>
+        <p:spPr>
+          <a:xfrm>
+            <a:off x="6406743" y="2453982"/>
+            <a:ext cx="2197531" cy="286893"/>
+          </a:xfrm>
+          <a:prstGeom prst="rect">
+            <a:avLst/>
+          </a:prstGeom>
+          <a:noFill/>
+        </p:spPr>
+        <p:txBody>
+          <a:bodyPr wrap="square" anchor="t" lIns="0" rIns="0" tIns="0" bIns="0">
+            <a:spAutoFit/>
+          </a:bodyPr>
+          <a:lstStyle/>
+          <a:p>
+            <a:pPr algn="l">
+              <a:lnSpc>
+                <a:spcPct val="100000"/>
+              </a:lnSpc>
+            </a:pPr>
+            <a:r>
+              <a:rPr sz="1350" b="1">
+                <a:solidFill>
+                  <a:srgbClr val="D20A2E"/>
+                </a:solidFill>
+                <a:latin typeface="Microsoft YaHei"/>
+              </a:rPr>
+              <a:t>源端速率</a:t>
+            </a:r>
+          </a:p>
+        </p:txBody>
+      </p:sp>
+      <p:sp>
+        <p:nvSpPr>
+          <p:cNvPr id="18" name="TextBox 17"/>
+          <p:cNvSpPr txBox="1"/>
+          <p:nvPr/>
+        </p:nvSpPr>
+        <p:spPr>
+          <a:xfrm>
+            <a:off x="6406743" y="2823171"/>
+            <a:ext cx="2197531" cy="1181900"/>
+          </a:xfrm>
+          <a:prstGeom prst="rect">
+            <a:avLst/>
+          </a:prstGeom>
+          <a:noFill/>
+        </p:spPr>
+        <p:txBody>
+          <a:bodyPr wrap="square" anchor="t" lIns="0" rIns="0" tIns="0" bIns="0">
+            <a:spAutoFit/>
+          </a:bodyPr>
+          <a:lstStyle/>
+          <a:p>
+            <a:pPr algn="l">
+              <a:lnSpc>
+                <a:spcPct val="102000"/>
+              </a:lnSpc>
+            </a:pPr>
+            <a:r>
+              <a:rPr sz="1050" b="1">
+                <a:solidFill>
+                  <a:srgbClr val="20242C"/>
+                </a:solidFill>
+                <a:latin typeface="Microsoft YaHei"/>
+              </a:rPr>
+              <a:t>代表</a:t>
+            </a:r>
+            <a:r>
+              <a:rPr sz="1050" b="0">
+                <a:solidFill>
+                  <a:srgbClr val="20242C"/>
+                </a:solidFill>
+                <a:latin typeface="Microsoft YaHei"/>
+              </a:rPr>
+              <a:t>：S1 族、S17 / S18 / S21 / S28。</a:t>
             </a:r>
           </a:p>
           <a:p>
@@ -12537,7 +13259,53 @@
               </a:spcBef>
             </a:pPr>
             <a:r>
-              <a:rPr sz="1200" b="1">
+              <a:rPr sz="1050" b="1">
+                <a:solidFill>
+                  <a:srgbClr val="20242C"/>
+                </a:solidFill>
+                <a:latin typeface="Microsoft YaHei"/>
+              </a:rPr>
+              <a:t>动手处</a:t>
+            </a:r>
+            <a:r>
+              <a:rPr sz="1050" b="0">
+                <a:solidFill>
+                  <a:srgbClr val="20242C"/>
+                </a:solidFill>
+                <a:latin typeface="Microsoft YaHei"/>
+              </a:rPr>
+              <a:t>：注入令牌桶。</a:t>
+            </a:r>
+          </a:p>
+          <a:p>
+            <a:pPr algn="l">
+              <a:lnSpc>
+                <a:spcPct val="102000"/>
+              </a:lnSpc>
+              <a:spcBef>
+                <a:spcPts val="600"/>
+              </a:spcBef>
+            </a:pPr>
+            <a:r>
+              <a:rPr sz="1050" b="1">
+                <a:solidFill>
+                  <a:srgbClr val="20242C"/>
+                </a:solidFill>
+                <a:latin typeface="Microsoft YaHei"/>
+              </a:rPr>
+              <a:t>优</a:t>
+            </a:r>
+            <a:r>
+              <a:rPr sz="1050" b="0">
+                <a:solidFill>
+                  <a:srgbClr val="20242C"/>
+                </a:solidFill>
+                <a:latin typeface="Microsoft YaHei"/>
+              </a:rPr>
+              <a:t>：直接控总量。</a:t>
+            </a:r>
+            <a:r>
+              <a:rPr sz="1050" b="1">
                 <a:solidFill>
                   <a:srgbClr val="20242C"/>
                 </a:solidFill>
@@ -12546,27 +13314,27 @@
               <a:t>缺</a:t>
             </a:r>
             <a:r>
-              <a:rPr sz="1200" b="0">
-                <a:solidFill>
-                  <a:srgbClr val="20242C"/>
-                </a:solidFill>
-                <a:latin typeface="Microsoft YaHei"/>
-              </a:rPr>
-              <a:t>：为空闲者保留的时隙直接浪费；帧长决定粒度。</a:t>
-            </a:r>
-          </a:p>
-        </p:txBody>
-      </p:sp>
-      <p:sp>
-        <p:nvSpPr>
-          <p:cNvPr id="16" name="Rectangle 15"/>
+              <a:rPr sz="1050" b="0">
+                <a:solidFill>
+                  <a:srgbClr val="20242C"/>
+                </a:solidFill>
+                <a:latin typeface="Microsoft YaHei"/>
+              </a:rPr>
+              <a:t>：闸门只能「扣住」，让出的槽被沿途吃掉。</a:t>
+            </a:r>
+          </a:p>
+        </p:txBody>
+      </p:sp>
+      <p:sp>
+        <p:nvSpPr>
+          <p:cNvPr id="19" name="Rectangle 18"/>
           <p:cNvSpPr/>
           <p:nvPr/>
         </p:nvSpPr>
         <p:spPr>
           <a:xfrm>
-            <a:off x="6205575" y="2422443"/>
-            <a:ext cx="2599867" cy="2616616"/>
+            <a:off x="9024899" y="2252814"/>
+            <a:ext cx="2599867" cy="1916849"/>
           </a:xfrm>
           <a:prstGeom prst="rect">
             <a:avLst/>
@@ -12605,14 +13373,14 @@
       </p:sp>
       <p:sp>
         <p:nvSpPr>
-          <p:cNvPr id="17" name="TextBox 16"/>
-          <p:cNvSpPr txBox="1"/>
-          <p:nvPr/>
-        </p:nvSpPr>
-        <p:spPr>
-          <a:xfrm>
-            <a:off x="6406743" y="2623611"/>
-            <a:ext cx="2197531" cy="314705"/>
+          <p:cNvPr id="20" name="TextBox 19"/>
+          <p:cNvSpPr txBox="1"/>
+          <p:nvPr/>
+        </p:nvSpPr>
+        <p:spPr>
+          <a:xfrm>
+            <a:off x="9226067" y="2553275"/>
+            <a:ext cx="2197531" cy="286893"/>
           </a:xfrm>
           <a:prstGeom prst="rect">
             <a:avLst/>
@@ -12631,27 +13399,27 @@
               </a:lnSpc>
             </a:pPr>
             <a:r>
-              <a:rPr sz="1500" b="1">
-                <a:solidFill>
-                  <a:srgbClr val="20242C"/>
-                </a:solidFill>
-                <a:latin typeface="Microsoft YaHei"/>
-              </a:rPr>
-              <a:t>⑦ 接收端驱动</a:t>
-            </a:r>
-          </a:p>
-        </p:txBody>
-      </p:sp>
-      <p:sp>
-        <p:nvSpPr>
-          <p:cNvPr id="18" name="TextBox 17"/>
-          <p:cNvSpPr txBox="1"/>
-          <p:nvPr/>
-        </p:nvSpPr>
-        <p:spPr>
-          <a:xfrm>
-            <a:off x="6406743" y="3020613"/>
-            <a:ext cx="2197531" cy="1853854"/>
+              <a:rPr sz="1350" b="1">
+                <a:solidFill>
+                  <a:srgbClr val="20242C"/>
+                </a:solidFill>
+                <a:latin typeface="Microsoft YaHei"/>
+              </a:rPr>
+              <a:t>源端窗口</a:t>
+            </a:r>
+          </a:p>
+        </p:txBody>
+      </p:sp>
+      <p:sp>
+        <p:nvSpPr>
+          <p:cNvPr id="21" name="TextBox 20"/>
+          <p:cNvSpPr txBox="1"/>
+          <p:nvPr/>
+        </p:nvSpPr>
+        <p:spPr>
+          <a:xfrm>
+            <a:off x="9226067" y="2922464"/>
+            <a:ext cx="2197531" cy="983315"/>
           </a:xfrm>
           <a:prstGeom prst="rect">
             <a:avLst/>
@@ -12670,7 +13438,7 @@
               </a:lnSpc>
             </a:pPr>
             <a:r>
-              <a:rPr sz="1200" b="1">
+              <a:rPr sz="1050" b="1">
                 <a:solidFill>
                   <a:srgbClr val="20242C"/>
                 </a:solidFill>
@@ -12679,13 +13447,13 @@
               <a:t>代表</a:t>
             </a:r>
             <a:r>
-              <a:rPr sz="1200" b="0">
-                <a:solidFill>
-                  <a:srgbClr val="20242C"/>
-                </a:solidFill>
-                <a:latin typeface="Microsoft YaHei"/>
-              </a:rPr>
-              <a:t>：Homa / NDP / pHost / ExpressPass。</a:t>
+              <a:rPr sz="1050" b="0">
+                <a:solidFill>
+                  <a:srgbClr val="20242C"/>
+                </a:solidFill>
+                <a:latin typeface="Microsoft YaHei"/>
+              </a:rPr>
+              <a:t>：S19 / S20。</a:t>
             </a:r>
           </a:p>
           <a:p>
@@ -12698,7 +13466,7 @@
               </a:spcBef>
             </a:pPr>
             <a:r>
-              <a:rPr sz="1200" b="1">
+              <a:rPr sz="1050" b="1">
                 <a:solidFill>
                   <a:srgbClr val="20242C"/>
                 </a:solidFill>
@@ -12707,13 +13475,13 @@
               <a:t>动手处</a:t>
             </a:r>
             <a:r>
-              <a:rPr sz="1200" b="0">
-                <a:solidFill>
-                  <a:srgbClr val="20242C"/>
-                </a:solidFill>
-                <a:latin typeface="Microsoft YaHei"/>
-              </a:rPr>
-              <a:t>：completer 授权。</a:t>
+              <a:rPr sz="1050" b="0">
+                <a:solidFill>
+                  <a:srgbClr val="20242C"/>
+                </a:solidFill>
+                <a:latin typeface="Microsoft YaHei"/>
+              </a:rPr>
+              <a:t>：在飞事务数。</a:t>
             </a:r>
           </a:p>
           <a:p>
@@ -12726,7 +13494,7 @@
               </a:spcBef>
             </a:pPr>
             <a:r>
-              <a:rPr sz="1200" b="1">
+              <a:rPr sz="1050" b="1">
                 <a:solidFill>
                   <a:srgbClr val="20242C"/>
                 </a:solidFill>
@@ -12735,26 +13503,16 @@
               <a:t>优</a:t>
             </a:r>
             <a:r>
-              <a:rPr sz="1200" b="0">
-                <a:solidFill>
-                  <a:srgbClr val="20242C"/>
-                </a:solidFill>
-                <a:latin typeface="Microsoft YaHei"/>
-              </a:rPr>
-              <a:t>：控制点在真正拥塞的下环侧；扣住授权不会造成气泡。</a:t>
-            </a:r>
-          </a:p>
-          <a:p>
-            <a:pPr algn="l">
-              <a:lnSpc>
-                <a:spcPct val="102000"/>
-              </a:lnSpc>
-              <a:spcBef>
-                <a:spcPts val="600"/>
-              </a:spcBef>
-            </a:pPr>
-            <a:r>
-              <a:rPr sz="1200" b="1">
+              <a:rPr sz="1050" b="0">
+                <a:solidFill>
+                  <a:srgbClr val="20242C"/>
+                </a:solidFill>
+                <a:latin typeface="Microsoft YaHei"/>
+              </a:rPr>
+              <a:t>：与 CHI 事务模型对齐。</a:t>
+            </a:r>
+            <a:r>
+              <a:rPr sz="1050" b="1">
                 <a:solidFill>
                   <a:srgbClr val="20242C"/>
                 </a:solidFill>
@@ -12763,27 +13521,27 @@
               <a:t>缺</a:t>
             </a:r>
             <a:r>
-              <a:rPr sz="1200" b="0">
-                <a:solidFill>
-                  <a:srgbClr val="20242C"/>
-                </a:solidFill>
-                <a:latin typeface="Microsoft YaHei"/>
-              </a:rPr>
-              <a:t>：要动事务层；拥塞不在接收端时无效。</a:t>
-            </a:r>
-          </a:p>
-        </p:txBody>
-      </p:sp>
-      <p:sp>
-        <p:nvSpPr>
-          <p:cNvPr id="19" name="Rectangle 18"/>
+              <a:rPr sz="1050" b="0">
+                <a:solidFill>
+                  <a:srgbClr val="20242C"/>
+                </a:solidFill>
+                <a:latin typeface="Microsoft YaHei"/>
+              </a:rPr>
+              <a:t>：不管瓶颈处先服务谁。</a:t>
+            </a:r>
+          </a:p>
+        </p:txBody>
+      </p:sp>
+      <p:sp>
+        <p:nvSpPr>
+          <p:cNvPr id="22" name="Rectangle 21"/>
           <p:cNvSpPr/>
           <p:nvPr/>
         </p:nvSpPr>
         <p:spPr>
           <a:xfrm>
-            <a:off x="9024899" y="2422443"/>
-            <a:ext cx="2599867" cy="2616616"/>
+            <a:off x="566928" y="4389120"/>
+            <a:ext cx="2599867" cy="1916849"/>
           </a:xfrm>
           <a:prstGeom prst="rect">
             <a:avLst/>
@@ -12822,14 +13580,14 @@
       </p:sp>
       <p:sp>
         <p:nvSpPr>
-          <p:cNvPr id="20" name="TextBox 19"/>
-          <p:cNvSpPr txBox="1"/>
-          <p:nvPr/>
-        </p:nvSpPr>
-        <p:spPr>
-          <a:xfrm>
-            <a:off x="9226067" y="2623611"/>
-            <a:ext cx="2197531" cy="314705"/>
+          <p:cNvPr id="23" name="TextBox 22"/>
+          <p:cNvSpPr txBox="1"/>
+          <p:nvPr/>
+        </p:nvSpPr>
+        <p:spPr>
+          <a:xfrm>
+            <a:off x="768096" y="4689580"/>
+            <a:ext cx="2197531" cy="286893"/>
           </a:xfrm>
           <a:prstGeom prst="rect">
             <a:avLst/>
@@ -12848,27 +13606,27 @@
               </a:lnSpc>
             </a:pPr>
             <a:r>
-              <a:rPr sz="1500" b="1">
-                <a:solidFill>
-                  <a:srgbClr val="20242C"/>
-                </a:solidFill>
-                <a:latin typeface="Microsoft YaHei"/>
-              </a:rPr>
-              <a:t>⑧ 显式速率反馈</a:t>
-            </a:r>
-          </a:p>
-        </p:txBody>
-      </p:sp>
-      <p:sp>
-        <p:nvSpPr>
-          <p:cNvPr id="21" name="TextBox 20"/>
-          <p:cNvSpPr txBox="1"/>
-          <p:nvPr/>
-        </p:nvSpPr>
-        <p:spPr>
-          <a:xfrm>
-            <a:off x="9226067" y="3020613"/>
-            <a:ext cx="2197531" cy="1853854"/>
+              <a:rPr sz="1350" b="1">
+                <a:solidFill>
+                  <a:srgbClr val="20242C"/>
+                </a:solidFill>
+                <a:latin typeface="Microsoft YaHei"/>
+              </a:rPr>
+              <a:t>环上仲裁</a:t>
+            </a:r>
+          </a:p>
+        </p:txBody>
+      </p:sp>
+      <p:sp>
+        <p:nvSpPr>
+          <p:cNvPr id="24" name="TextBox 23"/>
+          <p:cNvSpPr txBox="1"/>
+          <p:nvPr/>
+        </p:nvSpPr>
+        <p:spPr>
+          <a:xfrm>
+            <a:off x="768096" y="5058769"/>
+            <a:ext cx="2197531" cy="983315"/>
           </a:xfrm>
           <a:prstGeom prst="rect">
             <a:avLst/>
@@ -12887,7 +13645,7 @@
               </a:lnSpc>
             </a:pPr>
             <a:r>
-              <a:rPr sz="1200" b="1">
+              <a:rPr sz="1050" b="1">
                 <a:solidFill>
                   <a:srgbClr val="20242C"/>
                 </a:solidFill>
@@ -12896,13 +13654,13 @@
               <a:t>代表</a:t>
             </a:r>
             <a:r>
-              <a:rPr sz="1200" b="0">
-                <a:solidFill>
-                  <a:srgbClr val="20242C"/>
-                </a:solidFill>
-                <a:latin typeface="Microsoft YaHei"/>
-              </a:rPr>
-              <a:t>：XCP / RCP / HPCC。</a:t>
+              <a:rPr sz="1050" b="0">
+                <a:solidFill>
+                  <a:srgbClr val="20242C"/>
+                </a:solidFill>
+                <a:latin typeface="Microsoft YaHei"/>
+              </a:rPr>
+              <a:t>：I-tag / S22。</a:t>
             </a:r>
           </a:p>
           <a:p>
@@ -12915,7 +13673,7 @@
               </a:spcBef>
             </a:pPr>
             <a:r>
-              <a:rPr sz="1200" b="1">
+              <a:rPr sz="1050" b="1">
                 <a:solidFill>
                   <a:srgbClr val="20242C"/>
                 </a:solidFill>
@@ -12924,13 +13682,13 @@
               <a:t>动手处</a:t>
             </a:r>
             <a:r>
-              <a:rPr sz="1200" b="0">
-                <a:solidFill>
-                  <a:srgbClr val="20242C"/>
-                </a:solidFill>
-                <a:latin typeface="Microsoft YaHei"/>
-              </a:rPr>
-              <a:t>：瓶颈自己算速率并回传。</a:t>
+              <a:rPr sz="1050" b="0">
+                <a:solidFill>
+                  <a:srgbClr val="20242C"/>
+                </a:solidFill>
+                <a:latin typeface="Microsoft YaHei"/>
+              </a:rPr>
+              <a:t>：环上谁先用这一拍。</a:t>
             </a:r>
           </a:p>
           <a:p>
@@ -12943,7 +13701,7 @@
               </a:spcBef>
             </a:pPr>
             <a:r>
-              <a:rPr sz="1200" b="1">
+              <a:rPr sz="1050" b="1">
                 <a:solidFill>
                   <a:srgbClr val="20242C"/>
                 </a:solidFill>
@@ -12952,26 +13710,16 @@
               <a:t>优</a:t>
             </a:r>
             <a:r>
-              <a:rPr sz="1200" b="0">
-                <a:solidFill>
-                  <a:srgbClr val="20242C"/>
-                </a:solidFill>
-                <a:latin typeface="Microsoft YaHei"/>
-              </a:rPr>
-              <a:t>：源端不必猜；同一 hop 上所有核拿到同一个数，天然公平。</a:t>
-            </a:r>
-          </a:p>
-          <a:p>
-            <a:pPr algn="l">
-              <a:lnSpc>
-                <a:spcPct val="102000"/>
-              </a:lnSpc>
-              <a:spcBef>
-                <a:spcPts val="600"/>
-              </a:spcBef>
-            </a:pPr>
-            <a:r>
-              <a:rPr sz="1200" b="1">
+              <a:rPr sz="1050" b="0">
+                <a:solidFill>
+                  <a:srgbClr val="20242C"/>
+                </a:solidFill>
+                <a:latin typeface="Microsoft YaHei"/>
+              </a:rPr>
+              <a:t>：控制点就在拥塞 hop。</a:t>
+            </a:r>
+            <a:r>
+              <a:rPr sz="1050" b="1">
                 <a:solidFill>
                   <a:srgbClr val="20242C"/>
                 </a:solidFill>
@@ -12980,36 +13728,38 @@
               <a:t>缺</a:t>
             </a:r>
             <a:r>
-              <a:rPr sz="1200" b="0">
-                <a:solidFill>
-                  <a:srgbClr val="20242C"/>
-                </a:solidFill>
-                <a:latin typeface="Microsoft YaHei"/>
-              </a:rPr>
-              <a:t>：反馈信息量最大，总线最宽；收敛要多窗。</a:t>
-            </a:r>
-          </a:p>
-        </p:txBody>
-      </p:sp>
-      <p:sp>
-        <p:nvSpPr>
-          <p:cNvPr id="22" name="Rectangle 21"/>
+              <a:rPr sz="1050" b="0">
+                <a:solidFill>
+                  <a:srgbClr val="20242C"/>
+                </a:solidFill>
+                <a:latin typeface="Microsoft YaHei"/>
+              </a:rPr>
+              <a:t>：要动仲裁器。</a:t>
+            </a:r>
+          </a:p>
+        </p:txBody>
+      </p:sp>
+      <p:sp>
+        <p:nvSpPr>
+          <p:cNvPr id="25" name="Rectangle 24"/>
           <p:cNvSpPr/>
           <p:nvPr/>
         </p:nvSpPr>
         <p:spPr>
           <a:xfrm>
-            <a:off x="566928" y="5468112"/>
-            <a:ext cx="11057839" cy="859536"/>
+            <a:off x="3386251" y="4389120"/>
+            <a:ext cx="2599867" cy="1916849"/>
           </a:xfrm>
           <a:prstGeom prst="rect">
             <a:avLst/>
           </a:prstGeom>
           <a:solidFill>
-            <a:srgbClr val="D20A2E"/>
+            <a:srgbClr val="FFFFFF"/>
           </a:solidFill>
-          <a:ln>
-            <a:noFill/>
+          <a:ln w="12700">
+            <a:solidFill>
+              <a:srgbClr val="DCE3EA"/>
+            </a:solidFill>
           </a:ln>
           <a:effectLst/>
         </p:spPr>
@@ -13037,46 +13787,375 @@
       </p:sp>
       <p:sp>
         <p:nvSpPr>
-          <p:cNvPr id="23" name="TextBox 22"/>
-          <p:cNvSpPr txBox="1"/>
-          <p:nvPr/>
-        </p:nvSpPr>
-        <p:spPr>
-          <a:xfrm>
-            <a:off x="877824" y="5559552"/>
-            <a:ext cx="10436047" cy="676656"/>
-          </a:xfrm>
-          <a:prstGeom prst="rect">
-            <a:avLst/>
-          </a:prstGeom>
-          <a:noFill/>
-        </p:spPr>
-        <p:txBody>
-          <a:bodyPr wrap="square" anchor="ctr" lIns="0" rIns="0" tIns="0" bIns="0">
-            <a:spAutoFit/>
-          </a:bodyPr>
-          <a:lstStyle/>
-          <a:p>
-            <a:pPr algn="l">
-              <a:lnSpc>
-                <a:spcPct val="104000"/>
-              </a:lnSpc>
-            </a:pPr>
-            <a:r>
-              <a:rPr sz="1300" b="0">
-                <a:solidFill>
-                  <a:srgbClr val="FFFFFF"/>
-                </a:solidFill>
-                <a:latin typeface="Microsoft YaHei"/>
-              </a:rPr>
-              <a:t>第二个维度是「听什么信号」：本地观测 / 时延 / ECN / 显式等级 / 显式速率，与控制点正交 —— 同一执行器换个信号就是另一个方案（S17↔S18、S19↔S20）。</a:t>
-            </a:r>
-          </a:p>
-        </p:txBody>
-      </p:sp>
-      <p:sp>
-        <p:nvSpPr>
-          <p:cNvPr id="24" name="TextBox 23"/>
+          <p:cNvPr id="26" name="TextBox 25"/>
+          <p:cNvSpPr txBox="1"/>
+          <p:nvPr/>
+        </p:nvSpPr>
+        <p:spPr>
+          <a:xfrm>
+            <a:off x="3587419" y="4590288"/>
+            <a:ext cx="2197531" cy="286893"/>
+          </a:xfrm>
+          <a:prstGeom prst="rect">
+            <a:avLst/>
+          </a:prstGeom>
+          <a:noFill/>
+        </p:spPr>
+        <p:txBody>
+          <a:bodyPr wrap="square" anchor="t" lIns="0" rIns="0" tIns="0" bIns="0">
+            <a:spAutoFit/>
+          </a:bodyPr>
+          <a:lstStyle/>
+          <a:p>
+            <a:pPr algn="l">
+              <a:lnSpc>
+                <a:spcPct val="100000"/>
+              </a:lnSpc>
+            </a:pPr>
+            <a:r>
+              <a:rPr sz="1350" b="1">
+                <a:solidFill>
+                  <a:srgbClr val="20242C"/>
+                </a:solidFill>
+                <a:latin typeface="Microsoft YaHei"/>
+              </a:rPr>
+              <a:t>预约调度</a:t>
+            </a:r>
+          </a:p>
+        </p:txBody>
+      </p:sp>
+      <p:sp>
+        <p:nvSpPr>
+          <p:cNvPr id="27" name="TextBox 26"/>
+          <p:cNvSpPr txBox="1"/>
+          <p:nvPr/>
+        </p:nvSpPr>
+        <p:spPr>
+          <a:xfrm>
+            <a:off x="3587419" y="4959477"/>
+            <a:ext cx="2197531" cy="1181900"/>
+          </a:xfrm>
+          <a:prstGeom prst="rect">
+            <a:avLst/>
+          </a:prstGeom>
+          <a:noFill/>
+        </p:spPr>
+        <p:txBody>
+          <a:bodyPr wrap="square" anchor="t" lIns="0" rIns="0" tIns="0" bIns="0">
+            <a:spAutoFit/>
+          </a:bodyPr>
+          <a:lstStyle/>
+          <a:p>
+            <a:pPr algn="l">
+              <a:lnSpc>
+                <a:spcPct val="102000"/>
+              </a:lnSpc>
+            </a:pPr>
+            <a:r>
+              <a:rPr sz="1050" b="1">
+                <a:solidFill>
+                  <a:srgbClr val="20242C"/>
+                </a:solidFill>
+                <a:latin typeface="Microsoft YaHei"/>
+              </a:rPr>
+              <a:t>代表</a:t>
+            </a:r>
+            <a:r>
+              <a:rPr sz="1050" b="0">
+                <a:solidFill>
+                  <a:srgbClr val="20242C"/>
+                </a:solidFill>
+                <a:latin typeface="Microsoft YaHei"/>
+              </a:rPr>
+              <a:t>：S29（TDMA / Fastpass 类）。</a:t>
+            </a:r>
+          </a:p>
+          <a:p>
+            <a:pPr algn="l">
+              <a:lnSpc>
+                <a:spcPct val="102000"/>
+              </a:lnSpc>
+              <a:spcBef>
+                <a:spcPts val="600"/>
+              </a:spcBef>
+            </a:pPr>
+            <a:r>
+              <a:rPr sz="1050" b="1">
+                <a:solidFill>
+                  <a:srgbClr val="20242C"/>
+                </a:solidFill>
+                <a:latin typeface="Microsoft YaHei"/>
+              </a:rPr>
+              <a:t>动手处</a:t>
+            </a:r>
+            <a:r>
+              <a:rPr sz="1050" b="0">
+                <a:solidFill>
+                  <a:srgbClr val="20242C"/>
+                </a:solidFill>
+                <a:latin typeface="Microsoft YaHei"/>
+              </a:rPr>
+              <a:t>：预分配时隙。</a:t>
+            </a:r>
+          </a:p>
+          <a:p>
+            <a:pPr algn="l">
+              <a:lnSpc>
+                <a:spcPct val="102000"/>
+              </a:lnSpc>
+              <a:spcBef>
+                <a:spcPts val="600"/>
+              </a:spcBef>
+            </a:pPr>
+            <a:r>
+              <a:rPr sz="1050" b="1">
+                <a:solidFill>
+                  <a:srgbClr val="20242C"/>
+                </a:solidFill>
+                <a:latin typeface="Microsoft YaHei"/>
+              </a:rPr>
+              <a:t>优</a:t>
+            </a:r>
+            <a:r>
+              <a:rPr sz="1050" b="0">
+                <a:solidFill>
+                  <a:srgbClr val="20242C"/>
+                </a:solidFill>
+                <a:latin typeface="Microsoft YaHei"/>
+              </a:rPr>
+              <a:t>：拥塞不形成。</a:t>
+            </a:r>
+            <a:r>
+              <a:rPr sz="1050" b="1">
+                <a:solidFill>
+                  <a:srgbClr val="20242C"/>
+                </a:solidFill>
+                <a:latin typeface="Microsoft YaHei"/>
+              </a:rPr>
+              <a:t>缺</a:t>
+            </a:r>
+            <a:r>
+              <a:rPr sz="1050" b="0">
+                <a:solidFill>
+                  <a:srgbClr val="20242C"/>
+                </a:solidFill>
+                <a:latin typeface="Microsoft YaHei"/>
+              </a:rPr>
+              <a:t>：空闲时隙会浪费（S29 用 1 bit 回收）。</a:t>
+            </a:r>
+          </a:p>
+        </p:txBody>
+      </p:sp>
+      <p:sp>
+        <p:nvSpPr>
+          <p:cNvPr id="28" name="Rectangle 27"/>
+          <p:cNvSpPr/>
+          <p:nvPr/>
+        </p:nvSpPr>
+        <p:spPr>
+          <a:xfrm>
+            <a:off x="6205575" y="4389120"/>
+            <a:ext cx="2599867" cy="1916849"/>
+          </a:xfrm>
+          <a:prstGeom prst="rect">
+            <a:avLst/>
+          </a:prstGeom>
+          <a:solidFill>
+            <a:srgbClr val="FFFFFF"/>
+          </a:solidFill>
+          <a:ln w="12700">
+            <a:solidFill>
+              <a:srgbClr val="DCE3EA"/>
+            </a:solidFill>
+          </a:ln>
+          <a:effectLst/>
+        </p:spPr>
+        <p:style>
+          <a:lnRef idx="1">
+            <a:schemeClr val="accent1"/>
+          </a:lnRef>
+          <a:fillRef idx="3">
+            <a:schemeClr val="accent1"/>
+          </a:fillRef>
+          <a:effectRef idx="2">
+            <a:schemeClr val="accent1"/>
+          </a:effectRef>
+          <a:fontRef idx="minor">
+            <a:schemeClr val="lt1"/>
+          </a:fontRef>
+        </p:style>
+        <p:txBody>
+          <a:bodyPr rtlCol="0" anchor="ctr" wrap="square"/>
+          <a:lstStyle/>
+          <a:p>
+            <a:pPr algn="ctr"/>
+          </a:p>
+        </p:txBody>
+      </p:sp>
+      <p:sp>
+        <p:nvSpPr>
+          <p:cNvPr id="29" name="TextBox 28"/>
+          <p:cNvSpPr txBox="1"/>
+          <p:nvPr/>
+        </p:nvSpPr>
+        <p:spPr>
+          <a:xfrm>
+            <a:off x="6406743" y="4689580"/>
+            <a:ext cx="2197531" cy="286893"/>
+          </a:xfrm>
+          <a:prstGeom prst="rect">
+            <a:avLst/>
+          </a:prstGeom>
+          <a:noFill/>
+        </p:spPr>
+        <p:txBody>
+          <a:bodyPr wrap="square" anchor="t" lIns="0" rIns="0" tIns="0" bIns="0">
+            <a:spAutoFit/>
+          </a:bodyPr>
+          <a:lstStyle/>
+          <a:p>
+            <a:pPr algn="l">
+              <a:lnSpc>
+                <a:spcPct val="100000"/>
+              </a:lnSpc>
+            </a:pPr>
+            <a:r>
+              <a:rPr sz="1350" b="1">
+                <a:solidFill>
+                  <a:srgbClr val="20242C"/>
+                </a:solidFill>
+                <a:latin typeface="Microsoft YaHei"/>
+              </a:rPr>
+              <a:t>接收端授权</a:t>
+            </a:r>
+          </a:p>
+        </p:txBody>
+      </p:sp>
+      <p:sp>
+        <p:nvSpPr>
+          <p:cNvPr id="30" name="TextBox 29"/>
+          <p:cNvSpPr txBox="1"/>
+          <p:nvPr/>
+        </p:nvSpPr>
+        <p:spPr>
+          <a:xfrm>
+            <a:off x="6406743" y="5058769"/>
+            <a:ext cx="2197531" cy="983315"/>
+          </a:xfrm>
+          <a:prstGeom prst="rect">
+            <a:avLst/>
+          </a:prstGeom>
+          <a:noFill/>
+        </p:spPr>
+        <p:txBody>
+          <a:bodyPr wrap="square" anchor="t" lIns="0" rIns="0" tIns="0" bIns="0">
+            <a:spAutoFit/>
+          </a:bodyPr>
+          <a:lstStyle/>
+          <a:p>
+            <a:pPr algn="l">
+              <a:lnSpc>
+                <a:spcPct val="102000"/>
+              </a:lnSpc>
+            </a:pPr>
+            <a:r>
+              <a:rPr sz="1050" b="1">
+                <a:solidFill>
+                  <a:srgbClr val="20242C"/>
+                </a:solidFill>
+                <a:latin typeface="Microsoft YaHei"/>
+              </a:rPr>
+              <a:t>代表</a:t>
+            </a:r>
+            <a:r>
+              <a:rPr sz="1050" b="0">
+                <a:solidFill>
+                  <a:srgbClr val="20242C"/>
+                </a:solidFill>
+                <a:latin typeface="Microsoft YaHei"/>
+              </a:rPr>
+              <a:t>：S16（Homa / NDP 类）。</a:t>
+            </a:r>
+          </a:p>
+          <a:p>
+            <a:pPr algn="l">
+              <a:lnSpc>
+                <a:spcPct val="102000"/>
+              </a:lnSpc>
+              <a:spcBef>
+                <a:spcPts val="600"/>
+              </a:spcBef>
+            </a:pPr>
+            <a:r>
+              <a:rPr sz="1050" b="1">
+                <a:solidFill>
+                  <a:srgbClr val="20242C"/>
+                </a:solidFill>
+                <a:latin typeface="Microsoft YaHei"/>
+              </a:rPr>
+              <a:t>动手处</a:t>
+            </a:r>
+            <a:r>
+              <a:rPr sz="1050" b="0">
+                <a:solidFill>
+                  <a:srgbClr val="20242C"/>
+                </a:solidFill>
+                <a:latin typeface="Microsoft YaHei"/>
+              </a:rPr>
+              <a:t>：completer 的 DBIDResp。</a:t>
+            </a:r>
+          </a:p>
+          <a:p>
+            <a:pPr algn="l">
+              <a:lnSpc>
+                <a:spcPct val="102000"/>
+              </a:lnSpc>
+              <a:spcBef>
+                <a:spcPts val="600"/>
+              </a:spcBef>
+            </a:pPr>
+            <a:r>
+              <a:rPr sz="1050" b="1">
+                <a:solidFill>
+                  <a:srgbClr val="20242C"/>
+                </a:solidFill>
+                <a:latin typeface="Microsoft YaHei"/>
+              </a:rPr>
+              <a:t>优</a:t>
+            </a:r>
+            <a:r>
+              <a:rPr sz="1050" b="0">
+                <a:solidFill>
+                  <a:srgbClr val="20242C"/>
+                </a:solidFill>
+                <a:latin typeface="Microsoft YaHei"/>
+              </a:rPr>
+              <a:t>：控制点在真正拥塞的下环侧。</a:t>
+            </a:r>
+            <a:r>
+              <a:rPr sz="1050" b="1">
+                <a:solidFill>
+                  <a:srgbClr val="20242C"/>
+                </a:solidFill>
+                <a:latin typeface="Microsoft YaHei"/>
+              </a:rPr>
+              <a:t>缺</a:t>
+            </a:r>
+            <a:r>
+              <a:rPr sz="1050" b="0">
+                <a:solidFill>
+                  <a:srgbClr val="20242C"/>
+                </a:solidFill>
+                <a:latin typeface="Microsoft YaHei"/>
+              </a:rPr>
+              <a:t>：要动事务层。</a:t>
+            </a:r>
+          </a:p>
+        </p:txBody>
+      </p:sp>
+      <p:sp>
+        <p:nvSpPr>
+          <p:cNvPr id="31" name="TextBox 30"/>
           <p:cNvSpPr txBox="1"/>
           <p:nvPr/>
         </p:nvSpPr>
@@ -13443,7 +14522,7 @@
                 </a:solidFill>
                 <a:latin typeface="Microsoft YaHei"/>
               </a:rPr>
-              <a:t>列 = 控制点（决定天花板）；行 = 拥塞信号（决定盲区）。灰底 = 本研究已有方案，红框 = S1 所在格，绿框 = 本次补齐的四类。</a:t>
+              <a:t>列 = 控制点 = 第 18 页（决定天花板）；行 = 拥塞信号 = 第 17 页（决定盲区）。灰底 = 已有方案，红框 = S1，绿框 = 本次补齐。</a:t>
             </a:r>
           </a:p>
         </p:txBody>
@@ -13541,8 +14620,8 @@
         </p:nvSpPr>
         <p:spPr>
           <a:xfrm>
-            <a:off x="8723376" y="1630830"/>
-            <a:ext cx="2718511" cy="481583"/>
+            <a:off x="8723376" y="1704257"/>
+            <a:ext cx="2718511" cy="259080"/>
           </a:xfrm>
           <a:prstGeom prst="rect">
             <a:avLst/>
@@ -13567,7 +14646,7 @@
                 </a:solidFill>
                 <a:latin typeface="Microsoft YaHei"/>
               </a:rPr>
-              <a:t>S1 = 源端限速 · 速率型 × 显式拥塞等级</a:t>
+              <a:t>S1 = 源端速率 × 显式等级</a:t>
             </a:r>
           </a:p>
         </p:txBody>
@@ -13580,8 +14659,8 @@
         </p:nvSpPr>
         <p:spPr>
           <a:xfrm>
-            <a:off x="8723376" y="2194710"/>
-            <a:ext cx="2718511" cy="755812"/>
+            <a:off x="8723376" y="2045633"/>
+            <a:ext cx="2718511" cy="831463"/>
           </a:xfrm>
           <a:prstGeom prst="rect">
             <a:avLst/>
@@ -13600,7 +14679,7 @@
               </a:lnSpc>
             </a:pPr>
             <a:r>
-              <a:rPr sz="850" b="1">
+              <a:rPr sz="950" b="1">
                 <a:solidFill>
                   <a:srgbClr val="20242C"/>
                 </a:solidFill>
@@ -13609,13 +14688,13 @@
               <a:t>控制点</a:t>
             </a:r>
             <a:r>
-              <a:rPr sz="850" b="0">
-                <a:solidFill>
-                  <a:srgbClr val="20242C"/>
-                </a:solidFill>
-                <a:latin typeface="Microsoft YaHei"/>
-              </a:rPr>
-              <a:t>：每核每窗的整型注入预算，出口是令牌桶闸门 —— 第 ③ 类。</a:t>
+              <a:rPr sz="950" b="0">
+                <a:solidFill>
+                  <a:srgbClr val="20242C"/>
+                </a:solidFill>
+                <a:latin typeface="Microsoft YaHei"/>
+              </a:rPr>
+              <a:t>：「源端速率」列 —— 每核每窗的整型注入预算，出口是令牌桶。</a:t>
             </a:r>
           </a:p>
           <a:p>
@@ -13628,7 +14707,7 @@
               </a:spcBef>
             </a:pPr>
             <a:r>
-              <a:rPr sz="850" b="1">
+              <a:rPr sz="950" b="1">
                 <a:solidFill>
                   <a:srgbClr val="20242C"/>
                 </a:solidFill>
@@ -13637,13 +14716,13 @@
               <a:t>信号</a:t>
             </a:r>
             <a:r>
-              <a:rPr sz="850" b="0">
-                <a:solidFill>
-                  <a:srgbClr val="20242C"/>
-                </a:solidFill>
-                <a:latin typeface="Microsoft YaHei"/>
-              </a:rPr>
-              <a:t>：3 bit 拥塞等级，专用广播总线，固定 30 拍 —— 是「等级」而不是「速率」。同格还有 S1T 与 S15。</a:t>
+              <a:rPr sz="950" b="0">
+                <a:solidFill>
+                  <a:srgbClr val="20242C"/>
+                </a:solidFill>
+                <a:latin typeface="Microsoft YaHei"/>
+              </a:rPr>
+              <a:t>：「显式等级」行 —— 3 bit 拥塞等级，专用广播总线，固定 30 拍。同格还有 S1T 与 S15。</a:t>
             </a:r>
           </a:p>
         </p:txBody>
@@ -17306,7 +18385,7 @@
                 </a:solidFill>
                 <a:latin typeface="Microsoft YaHei"/>
               </a:rPr>
-              <a:t>八类里原本没有代表方案的类数</a:t>
+              <a:t>二维表里原本空着的格子数</a:t>
             </a:r>
           </a:p>
           <a:p>
@@ -19612,8 +20691,8 @@
         </p:blipFill>
         <p:spPr>
           <a:xfrm>
-            <a:off x="566928" y="1673215"/>
-            <a:ext cx="7452360" cy="3566433"/>
+            <a:off x="566928" y="1609250"/>
+            <a:ext cx="7452360" cy="3694362"/>
           </a:xfrm>
           <a:prstGeom prst="rect">
             <a:avLst/>
@@ -19628,7 +20707,7 @@
         </p:nvSpPr>
         <p:spPr>
           <a:xfrm>
-            <a:off x="566928" y="5349376"/>
+            <a:off x="566928" y="5413341"/>
             <a:ext cx="7452360" cy="384048"/>
           </a:xfrm>
           <a:prstGeom prst="rect">
@@ -19654,7 +20733,7 @@
                 </a:solidFill>
                 <a:latin typeface="Microsoft YaHei"/>
               </a:rPr>
-              <a:t>红线 = 每个公平目标下的理论最高带宽；点 = 官方 K = 20000 实测。其中 I-tag 点只是 S0 的 t_inj / hold 调参，不是独立机制。</a:t>
+              <a:t>红线 = 每个公平目标下的理论最高带宽；13 个点 = 官方 K = 20000 全部实测方案（含 S26–S29）。I-tag 只是 S0 的 t_inj / hold 调参，不是独立机制。</a:t>
             </a:r>
           </a:p>
         </p:txBody>
@@ -19707,7 +20786,7 @@
         <p:spPr>
           <a:xfrm>
             <a:off x="8403336" y="1408176"/>
-            <a:ext cx="3221431" cy="1473060"/>
+            <a:ext cx="3221431" cy="2125856"/>
           </a:xfrm>
           <a:prstGeom prst="rect">
             <a:avLst/>
@@ -19752,7 +20831,7 @@
         </p:nvSpPr>
         <p:spPr>
           <a:xfrm>
-            <a:off x="8586215" y="1591056"/>
+            <a:off x="8586215" y="1689654"/>
             <a:ext cx="2855671" cy="259080"/>
           </a:xfrm>
           <a:prstGeom prst="rect">
@@ -19791,8 +20870,8 @@
         </p:nvSpPr>
         <p:spPr>
           <a:xfrm>
-            <a:off x="8586215" y="1932432"/>
-            <a:ext cx="2855671" cy="1172992"/>
+            <a:off x="8586215" y="2031030"/>
+            <a:ext cx="2855671" cy="1258100"/>
           </a:xfrm>
           <a:prstGeom prst="rect">
             <a:avLst/>
@@ -19811,7 +20890,7 @@
               </a:lnSpc>
             </a:pPr>
             <a:r>
-              <a:rPr sz="800" b="1">
+              <a:rPr sz="1050" b="1">
                 <a:solidFill>
                   <a:srgbClr val="20242C"/>
                 </a:solidFill>
@@ -19820,13 +20899,13 @@
               <a:t>λc</a:t>
             </a:r>
             <a:r>
-              <a:rPr sz="800" b="0">
-                <a:solidFill>
-                  <a:srgbClr val="20242C"/>
-                </a:solidFill>
-                <a:latin typeface="Microsoft YaHei"/>
-              </a:rPr>
-              <a:t>：第 c 个核的事务速率；十个核就是十个待选择的速率。</a:t>
+              <a:rPr sz="1050" b="0">
+                <a:solidFill>
+                  <a:srgbClr val="20242C"/>
+                </a:solidFill>
+                <a:latin typeface="Microsoft YaHei"/>
+              </a:rPr>
+              <a:t>：第 c 个核的事务速率。</a:t>
             </a:r>
           </a:p>
           <a:p>
@@ -19839,22 +20918,22 @@
               </a:spcBef>
             </a:pPr>
             <a:r>
-              <a:rPr sz="800" b="1">
-                <a:solidFill>
-                  <a:srgbClr val="20242C"/>
-                </a:solidFill>
-                <a:latin typeface="Microsoft YaHei"/>
-              </a:rPr>
-              <a:t>链路占用表</a:t>
-            </a:r>
-            <a:r>
-              <a:rPr sz="800" b="0">
-                <a:solidFill>
-                  <a:srgbClr val="20242C"/>
-                </a:solidFill>
-                <a:latin typeface="Microsoft YaHei"/>
-              </a:rPr>
-              <a:t>：每个核发一笔事务，会占哪些链路、各占几拍。路由和握手固定后，这张表也是固定的。</a:t>
+              <a:rPr sz="1050" b="1">
+                <a:solidFill>
+                  <a:srgbClr val="20242C"/>
+                </a:solidFill>
+                <a:latin typeface="Microsoft YaHei"/>
+              </a:rPr>
+              <a:t>占用表</a:t>
+            </a:r>
+            <a:r>
+              <a:rPr sz="1050" b="0">
+                <a:solidFill>
+                  <a:srgbClr val="20242C"/>
+                </a:solidFill>
+                <a:latin typeface="Microsoft YaHei"/>
+              </a:rPr>
+              <a:t>：每笔事务占哪些链路、各几拍；路由固定后这张表就固定。</a:t>
             </a:r>
           </a:p>
           <a:p>
@@ -19867,7 +20946,7 @@
               </a:spcBef>
             </a:pPr>
             <a:r>
-              <a:rPr sz="800" b="1">
+              <a:rPr sz="1050" b="1">
                 <a:solidFill>
                   <a:srgbClr val="20242C"/>
                 </a:solidFill>
@@ -19876,13 +20955,13 @@
               <a:t>J</a:t>
             </a:r>
             <a:r>
-              <a:rPr sz="800" b="0">
-                <a:solidFill>
-                  <a:srgbClr val="20242C"/>
-                </a:solidFill>
-                <a:latin typeface="Microsoft YaHei"/>
-              </a:rPr>
-              <a:t>：本次要求的最低 Jain 公平度，例如 0.95。</a:t>
+              <a:rPr sz="1050" b="0">
+                <a:solidFill>
+                  <a:srgbClr val="20242C"/>
+                </a:solidFill>
+                <a:latin typeface="Microsoft YaHei"/>
+              </a:rPr>
+              <a:t>：要求的最低 100 拍 Jain。</a:t>
             </a:r>
           </a:p>
           <a:p>
@@ -19895,7 +20974,7 @@
               </a:spcBef>
             </a:pPr>
             <a:r>
-              <a:rPr sz="800" b="1">
+              <a:rPr sz="1050" b="1">
                 <a:solidFill>
                   <a:srgbClr val="20242C"/>
                 </a:solidFill>
@@ -19904,13 +20983,13 @@
               <a:t>R(J)</a:t>
             </a:r>
             <a:r>
-              <a:rPr sz="800" b="0">
-                <a:solidFill>
-                  <a:srgbClr val="20242C"/>
-                </a:solidFill>
-                <a:latin typeface="Microsoft YaHei"/>
-              </a:rPr>
-              <a:t>：在公平度不低于 J 的前提下，所有核合计最多能跑多快。</a:t>
+              <a:rPr sz="1050" b="0">
+                <a:solidFill>
+                  <a:srgbClr val="20242C"/>
+                </a:solidFill>
+                <a:latin typeface="Microsoft YaHei"/>
+              </a:rPr>
+              <a:t>：公平度 ≥ J 时的最高总带宽。</a:t>
             </a:r>
           </a:p>
         </p:txBody>
@@ -19923,8 +21002,8 @@
         </p:nvSpPr>
         <p:spPr>
           <a:xfrm>
-            <a:off x="8403336" y="3027540"/>
-            <a:ext cx="3221431" cy="1043418"/>
+            <a:off x="8403336" y="3680336"/>
+            <a:ext cx="3221431" cy="1375554"/>
           </a:xfrm>
           <a:prstGeom prst="rect">
             <a:avLst/>
@@ -19967,8 +21046,8 @@
         </p:nvSpPr>
         <p:spPr>
           <a:xfrm>
-            <a:off x="8714232" y="3118980"/>
-            <a:ext cx="2599639" cy="860538"/>
+            <a:off x="8714232" y="3771776"/>
+            <a:ext cx="2599639" cy="1192674"/>
           </a:xfrm>
           <a:prstGeom prst="rect">
             <a:avLst/>
@@ -19987,13 +21066,13 @@
               </a:lnSpc>
             </a:pPr>
             <a:r>
-              <a:rPr sz="1100" b="0">
+              <a:rPr sz="1200" b="0">
                 <a:solidFill>
                   <a:srgbClr val="FFFFFF"/>
                 </a:solidFill>
                 <a:latin typeface="Microsoft YaHei"/>
               </a:rPr>
-              <a:t>一个红线点怎么来：先固定 J，再尝试十个核的所有速率组合；任何链路都不能超过每拍 1 flit，最后保留总带宽最高的组合。</a:t>
+              <a:t>红线点：固定 J，枚举十个核的速率组合，链路每拍 ≤ 1 flit，取总带宽最高的那个。J 从低到高逐点重算即得整条红线（凸优化全局上界，不是对仿真点拟合）。</a:t>
             </a:r>
           </a:p>
         </p:txBody>
@@ -20006,8 +21085,8 @@
         </p:nvSpPr>
         <p:spPr>
           <a:xfrm>
-            <a:off x="8403336" y="4217262"/>
-            <a:ext cx="3221431" cy="941122"/>
+            <a:off x="8403336" y="5202194"/>
+            <a:ext cx="3221431" cy="1125453"/>
           </a:xfrm>
           <a:prstGeom prst="rect">
             <a:avLst/>
@@ -20050,8 +21129,8 @@
         </p:nvSpPr>
         <p:spPr>
           <a:xfrm>
-            <a:off x="8714232" y="4308702"/>
-            <a:ext cx="2599639" cy="758242"/>
+            <a:off x="8714232" y="5293634"/>
+            <a:ext cx="2599639" cy="942573"/>
           </a:xfrm>
           <a:prstGeom prst="rect">
             <a:avLst/>
@@ -20070,103 +21149,20 @@
               </a:lnSpc>
             </a:pPr>
             <a:r>
-              <a:rPr sz="1150" b="0">
+              <a:rPr sz="1200" b="0">
                 <a:solidFill>
                   <a:srgbClr val="FFFFFF"/>
                 </a:solidFill>
                 <a:latin typeface="Microsoft YaHei"/>
               </a:rPr>
-              <a:t>把 J 从低到高逐点重算，就得到整条红线。这是标准凸优化的全局上界（只有数值求解误差），不是对仿真点做拟合。</a:t>
-            </a:r>
-          </a:p>
-        </p:txBody>
-      </p:sp>
-      <p:sp>
-        <p:nvSpPr>
-          <p:cNvPr id="18" name="Rectangle 17"/>
-          <p:cNvSpPr/>
-          <p:nvPr/>
-        </p:nvSpPr>
-        <p:spPr>
-          <a:xfrm>
-            <a:off x="8403336" y="5304689"/>
-            <a:ext cx="3221431" cy="1022958"/>
-          </a:xfrm>
-          <a:prstGeom prst="rect">
-            <a:avLst/>
-          </a:prstGeom>
-          <a:solidFill>
-            <a:srgbClr val="D20A2E"/>
-          </a:solidFill>
-          <a:ln>
-            <a:noFill/>
-          </a:ln>
-          <a:effectLst/>
-        </p:spPr>
-        <p:style>
-          <a:lnRef idx="1">
-            <a:schemeClr val="accent1"/>
-          </a:lnRef>
-          <a:fillRef idx="3">
-            <a:schemeClr val="accent1"/>
-          </a:fillRef>
-          <a:effectRef idx="2">
-            <a:schemeClr val="accent1"/>
-          </a:effectRef>
-          <a:fontRef idx="minor">
-            <a:schemeClr val="lt1"/>
-          </a:fontRef>
-        </p:style>
-        <p:txBody>
-          <a:bodyPr rtlCol="0" anchor="ctr" wrap="square"/>
-          <a:lstStyle/>
-          <a:p>
-            <a:pPr algn="ctr"/>
-          </a:p>
-        </p:txBody>
-      </p:sp>
-      <p:sp>
-        <p:nvSpPr>
-          <p:cNvPr id="19" name="TextBox 18"/>
-          <p:cNvSpPr txBox="1"/>
-          <p:nvPr/>
-        </p:nvSpPr>
-        <p:spPr>
-          <a:xfrm>
-            <a:off x="8714232" y="5396129"/>
-            <a:ext cx="2599639" cy="840078"/>
-          </a:xfrm>
-          <a:prstGeom prst="rect">
-            <a:avLst/>
-          </a:prstGeom>
-          <a:noFill/>
-        </p:spPr>
-        <p:txBody>
-          <a:bodyPr wrap="square" anchor="ctr" lIns="0" rIns="0" tIns="0" bIns="0">
-            <a:spAutoFit/>
-          </a:bodyPr>
-          <a:lstStyle/>
-          <a:p>
-            <a:pPr algn="l">
-              <a:lnSpc>
-                <a:spcPct val="104000"/>
-              </a:lnSpc>
-            </a:pPr>
-            <a:r>
-              <a:rPr sz="1050" b="0">
-                <a:solidFill>
-                  <a:srgbClr val="FFFFFF"/>
-                </a:solidFill>
-                <a:latin typeface="Microsoft YaHei"/>
-              </a:rPr>
-              <a:t>读图：红线上 = 该公平度下理论能做到的最好结果；红线下 = 实际机制损失；红线上方 = 资源容量不允许。J = 1 的最右端就是等速率上限 R* = 5.7143。</a:t>
-            </a:r>
-          </a:p>
-        </p:txBody>
-      </p:sp>
-      <p:sp>
-        <p:nvSpPr>
-          <p:cNvPr id="20" name="TextBox 19"/>
+              <a:t>红线上 = 该公平度下理论最好；红线下 = 机制损失；红线上方不可能。最右端 J=1 即 R* = 5.7143。</a:t>
+            </a:r>
+          </a:p>
+        </p:txBody>
+      </p:sp>
+      <p:sp>
+        <p:nvSpPr>
+          <p:cNvPr id="18" name="TextBox 17"/>
           <p:cNvSpPr txBox="1"/>
           <p:nvPr/>
         </p:nvSpPr>
@@ -33636,7 +34632,7 @@
         </p:nvSpPr>
         <p:spPr>
           <a:xfrm>
-            <a:off x="9226067" y="2453396"/>
+            <a:off x="9226067" y="2566873"/>
             <a:ext cx="2197531" cy="314705"/>
           </a:xfrm>
           <a:prstGeom prst="rect">
@@ -33675,8 +34671,8 @@
         </p:nvSpPr>
         <p:spPr>
           <a:xfrm>
-            <a:off x="9226067" y="2850398"/>
-            <a:ext cx="2197531" cy="2194285"/>
+            <a:off x="9226067" y="2963875"/>
+            <a:ext cx="2197531" cy="1967331"/>
           </a:xfrm>
           <a:prstGeom prst="rect">
             <a:avLst/>
@@ -33695,7 +34691,7 @@
               </a:lnSpc>
             </a:pPr>
             <a:r>
-              <a:rPr sz="850" b="0">
+              <a:rPr sz="900" b="0">
                 <a:solidFill>
                   <a:srgbClr val="20242C"/>
                 </a:solidFill>
@@ -33714,13 +34710,13 @@
               </a:spcBef>
             </a:pPr>
             <a:r>
-              <a:rPr sz="850" b="0">
-                <a:solidFill>
-                  <a:srgbClr val="20242C"/>
-                </a:solidFill>
-                <a:latin typeface="Microsoft YaHei"/>
-              </a:rPr>
-              <a:t>八类分类里原本空着的四类已全部实现并实测：自适应路由（S26）与逐跳背压（S27）结构性失效，显式速率要么不动公平（S28）要么用 40% 带宽换公平（S28S），只有预约调度（S29，复用让位执行器）三条轴全面优于 S1。</a:t>
+              <a:rPr sz="900" b="0">
+                <a:solidFill>
+                  <a:srgbClr val="20242C"/>
+                </a:solidFill>
+                <a:latin typeface="Microsoft YaHei"/>
+              </a:rPr>
+              <a:t>第 19 页空着的四格已实测：S26 / S27 结构性失效，S28 不动公平，S28S 用 40% 带宽换公平，只有 S29 三条轴优于 S1。</a:t>
             </a:r>
           </a:p>
           <a:p>
@@ -33733,7 +34729,7 @@
               </a:spcBef>
             </a:pPr>
             <a:r>
-              <a:rPr sz="850" b="0">
+              <a:rPr sz="900" b="0">
                 <a:solidFill>
                   <a:srgbClr val="20242C"/>
                 </a:solidFill>
@@ -33752,7 +34748,7 @@
               </a:spcBef>
             </a:pPr>
             <a:r>
-              <a:rPr sz="850" b="1">
+              <a:rPr sz="900" b="1">
                 <a:solidFill>
                   <a:srgbClr val="D20A2E"/>
                 </a:solidFill>

</xml_diff>